<commit_message>
Added Hardware spec on slides
</commit_message>
<xml_diff>
--- a/Slides/Slides.pptx
+++ b/Slides/Slides.pptx
@@ -9,6 +9,9 @@
     <p:sldId id="257" r:id="rId3"/>
     <p:sldId id="258" r:id="rId4"/>
     <p:sldId id="259" r:id="rId5"/>
+    <p:sldId id="262" r:id="rId6"/>
+    <p:sldId id="261" r:id="rId7"/>
+    <p:sldId id="260" r:id="rId8"/>
   </p:sldIdLst>
   <p:sldSz cx="9144000" cy="6858000" type="screen4x3"/>
   <p:notesSz cx="6858000" cy="9144000"/>
@@ -109,7 +112,7 @@
   </p:defaultTextStyle>
   <p:extLst>
     <p:ext uri="{EFAFB233-063F-42B5-8137-9DF3F51BA10A}">
-      <p15:sldGuideLst xmlns="" xmlns:p15="http://schemas.microsoft.com/office/powerpoint/2012/main">
+      <p15:sldGuideLst xmlns:p15="http://schemas.microsoft.com/office/powerpoint/2012/main">
         <p15:guide id="1" orient="horz" pos="2160">
           <p15:clr>
             <a:srgbClr val="A4A3A4"/>
@@ -168,10 +171,9 @@
           </a:lstStyle>
           <a:p>
             <a:r>
-              <a:rPr lang="en-US" smtClean="0"/>
+              <a:rPr lang="en-US"/>
               <a:t>Click to edit Master title style</a:t>
             </a:r>
-            <a:endParaRPr lang="en-US"/>
           </a:p>
         </p:txBody>
       </p:sp>
@@ -233,10 +235,9 @@
           </a:lstStyle>
           <a:p>
             <a:r>
-              <a:rPr lang="en-US" smtClean="0"/>
+              <a:rPr lang="en-US"/>
               <a:t>Click to edit Master subtitle style</a:t>
             </a:r>
-            <a:endParaRPr lang="en-US"/>
           </a:p>
         </p:txBody>
       </p:sp>
@@ -257,7 +258,7 @@
           <a:p>
             <a:fld id="{842CD987-D5F0-423A-B571-656612AAA3E1}" type="datetimeFigureOut">
               <a:rPr lang="en-US" smtClean="0"/>
-              <a:t>11/20/2017</a:t>
+              <a:t>1/15/2026</a:t>
             </a:fld>
             <a:endParaRPr lang="en-US"/>
           </a:p>
@@ -346,10 +347,9 @@
           <a:lstStyle/>
           <a:p>
             <a:r>
-              <a:rPr lang="en-US" smtClean="0"/>
+              <a:rPr lang="en-US"/>
               <a:t>Click to edit Master title style</a:t>
             </a:r>
-            <a:endParaRPr lang="en-US"/>
           </a:p>
         </p:txBody>
       </p:sp>
@@ -370,38 +370,37 @@
           <a:p>
             <a:pPr lvl="0"/>
             <a:r>
-              <a:rPr lang="en-US" smtClean="0"/>
+              <a:rPr lang="en-US"/>
               <a:t>Click to edit Master text styles</a:t>
             </a:r>
           </a:p>
           <a:p>
             <a:pPr lvl="1"/>
             <a:r>
-              <a:rPr lang="en-US" smtClean="0"/>
+              <a:rPr lang="en-US"/>
               <a:t>Second level</a:t>
             </a:r>
           </a:p>
           <a:p>
             <a:pPr lvl="2"/>
             <a:r>
-              <a:rPr lang="en-US" smtClean="0"/>
+              <a:rPr lang="en-US"/>
               <a:t>Third level</a:t>
             </a:r>
           </a:p>
           <a:p>
             <a:pPr lvl="3"/>
             <a:r>
-              <a:rPr lang="en-US" smtClean="0"/>
+              <a:rPr lang="en-US"/>
               <a:t>Fourth level</a:t>
             </a:r>
           </a:p>
           <a:p>
             <a:pPr lvl="4"/>
             <a:r>
-              <a:rPr lang="en-US" smtClean="0"/>
+              <a:rPr lang="en-US"/>
               <a:t>Fifth level</a:t>
             </a:r>
-            <a:endParaRPr lang="en-US"/>
           </a:p>
         </p:txBody>
       </p:sp>
@@ -422,7 +421,7 @@
           <a:p>
             <a:fld id="{842CD987-D5F0-423A-B571-656612AAA3E1}" type="datetimeFigureOut">
               <a:rPr lang="en-US" smtClean="0"/>
-              <a:t>11/20/2017</a:t>
+              <a:t>1/15/2026</a:t>
             </a:fld>
             <a:endParaRPr lang="en-US"/>
           </a:p>
@@ -516,10 +515,9 @@
           <a:lstStyle/>
           <a:p>
             <a:r>
-              <a:rPr lang="en-US" smtClean="0"/>
+              <a:rPr lang="en-US"/>
               <a:t>Click to edit Master title style</a:t>
             </a:r>
-            <a:endParaRPr lang="en-US"/>
           </a:p>
         </p:txBody>
       </p:sp>
@@ -545,38 +543,37 @@
           <a:p>
             <a:pPr lvl="0"/>
             <a:r>
-              <a:rPr lang="en-US" smtClean="0"/>
+              <a:rPr lang="en-US"/>
               <a:t>Click to edit Master text styles</a:t>
             </a:r>
           </a:p>
           <a:p>
             <a:pPr lvl="1"/>
             <a:r>
-              <a:rPr lang="en-US" smtClean="0"/>
+              <a:rPr lang="en-US"/>
               <a:t>Second level</a:t>
             </a:r>
           </a:p>
           <a:p>
             <a:pPr lvl="2"/>
             <a:r>
-              <a:rPr lang="en-US" smtClean="0"/>
+              <a:rPr lang="en-US"/>
               <a:t>Third level</a:t>
             </a:r>
           </a:p>
           <a:p>
             <a:pPr lvl="3"/>
             <a:r>
-              <a:rPr lang="en-US" smtClean="0"/>
+              <a:rPr lang="en-US"/>
               <a:t>Fourth level</a:t>
             </a:r>
           </a:p>
           <a:p>
             <a:pPr lvl="4"/>
             <a:r>
-              <a:rPr lang="en-US" smtClean="0"/>
+              <a:rPr lang="en-US"/>
               <a:t>Fifth level</a:t>
             </a:r>
-            <a:endParaRPr lang="en-US"/>
           </a:p>
         </p:txBody>
       </p:sp>
@@ -597,7 +594,7 @@
           <a:p>
             <a:fld id="{842CD987-D5F0-423A-B571-656612AAA3E1}" type="datetimeFigureOut">
               <a:rPr lang="en-US" smtClean="0"/>
-              <a:t>11/20/2017</a:t>
+              <a:t>1/15/2026</a:t>
             </a:fld>
             <a:endParaRPr lang="en-US"/>
           </a:p>
@@ -686,10 +683,9 @@
           <a:lstStyle/>
           <a:p>
             <a:r>
-              <a:rPr lang="en-US" smtClean="0"/>
+              <a:rPr lang="en-US"/>
               <a:t>Click to edit Master title style</a:t>
             </a:r>
-            <a:endParaRPr lang="en-US"/>
           </a:p>
         </p:txBody>
       </p:sp>
@@ -710,38 +706,37 @@
           <a:p>
             <a:pPr lvl="0"/>
             <a:r>
-              <a:rPr lang="en-US" smtClean="0"/>
+              <a:rPr lang="en-US"/>
               <a:t>Click to edit Master text styles</a:t>
             </a:r>
           </a:p>
           <a:p>
             <a:pPr lvl="1"/>
             <a:r>
-              <a:rPr lang="en-US" smtClean="0"/>
+              <a:rPr lang="en-US"/>
               <a:t>Second level</a:t>
             </a:r>
           </a:p>
           <a:p>
             <a:pPr lvl="2"/>
             <a:r>
-              <a:rPr lang="en-US" smtClean="0"/>
+              <a:rPr lang="en-US"/>
               <a:t>Third level</a:t>
             </a:r>
           </a:p>
           <a:p>
             <a:pPr lvl="3"/>
             <a:r>
-              <a:rPr lang="en-US" smtClean="0"/>
+              <a:rPr lang="en-US"/>
               <a:t>Fourth level</a:t>
             </a:r>
           </a:p>
           <a:p>
             <a:pPr lvl="4"/>
             <a:r>
-              <a:rPr lang="en-US" smtClean="0"/>
+              <a:rPr lang="en-US"/>
               <a:t>Fifth level</a:t>
             </a:r>
-            <a:endParaRPr lang="en-US"/>
           </a:p>
         </p:txBody>
       </p:sp>
@@ -762,7 +757,7 @@
           <a:p>
             <a:fld id="{842CD987-D5F0-423A-B571-656612AAA3E1}" type="datetimeFigureOut">
               <a:rPr lang="en-US" smtClean="0"/>
-              <a:t>11/20/2017</a:t>
+              <a:t>1/15/2026</a:t>
             </a:fld>
             <a:endParaRPr lang="en-US"/>
           </a:p>
@@ -860,10 +855,9 @@
           </a:lstStyle>
           <a:p>
             <a:r>
-              <a:rPr lang="en-US" smtClean="0"/>
+              <a:rPr lang="en-US"/>
               <a:t>Click to edit Master title style</a:t>
             </a:r>
-            <a:endParaRPr lang="en-US"/>
           </a:p>
         </p:txBody>
       </p:sp>
@@ -980,7 +974,7 @@
           <a:p>
             <a:pPr lvl="0"/>
             <a:r>
-              <a:rPr lang="en-US" smtClean="0"/>
+              <a:rPr lang="en-US"/>
               <a:t>Click to edit Master text styles</a:t>
             </a:r>
           </a:p>
@@ -1003,7 +997,7 @@
           <a:p>
             <a:fld id="{842CD987-D5F0-423A-B571-656612AAA3E1}" type="datetimeFigureOut">
               <a:rPr lang="en-US" smtClean="0"/>
-              <a:t>11/20/2017</a:t>
+              <a:t>1/15/2026</a:t>
             </a:fld>
             <a:endParaRPr lang="en-US"/>
           </a:p>
@@ -1092,10 +1086,9 @@
           <a:lstStyle/>
           <a:p>
             <a:r>
-              <a:rPr lang="en-US" smtClean="0"/>
+              <a:rPr lang="en-US"/>
               <a:t>Click to edit Master title style</a:t>
             </a:r>
-            <a:endParaRPr lang="en-US"/>
           </a:p>
         </p:txBody>
       </p:sp>
@@ -1121,38 +1114,37 @@
           <a:p>
             <a:pPr lvl="0"/>
             <a:r>
-              <a:rPr lang="en-US" smtClean="0"/>
+              <a:rPr lang="en-US"/>
               <a:t>Click to edit Master text styles</a:t>
             </a:r>
           </a:p>
           <a:p>
             <a:pPr lvl="1"/>
             <a:r>
-              <a:rPr lang="en-US" smtClean="0"/>
+              <a:rPr lang="en-US"/>
               <a:t>Second level</a:t>
             </a:r>
           </a:p>
           <a:p>
             <a:pPr lvl="2"/>
             <a:r>
-              <a:rPr lang="en-US" smtClean="0"/>
+              <a:rPr lang="en-US"/>
               <a:t>Third level</a:t>
             </a:r>
           </a:p>
           <a:p>
             <a:pPr lvl="3"/>
             <a:r>
-              <a:rPr lang="en-US" smtClean="0"/>
+              <a:rPr lang="en-US"/>
               <a:t>Fourth level</a:t>
             </a:r>
           </a:p>
           <a:p>
             <a:pPr lvl="4"/>
             <a:r>
-              <a:rPr lang="en-US" smtClean="0"/>
+              <a:rPr lang="en-US"/>
               <a:t>Fifth level</a:t>
             </a:r>
-            <a:endParaRPr lang="en-US"/>
           </a:p>
         </p:txBody>
       </p:sp>
@@ -1178,38 +1170,37 @@
           <a:p>
             <a:pPr lvl="0"/>
             <a:r>
-              <a:rPr lang="en-US" smtClean="0"/>
+              <a:rPr lang="en-US"/>
               <a:t>Click to edit Master text styles</a:t>
             </a:r>
           </a:p>
           <a:p>
             <a:pPr lvl="1"/>
             <a:r>
-              <a:rPr lang="en-US" smtClean="0"/>
+              <a:rPr lang="en-US"/>
               <a:t>Second level</a:t>
             </a:r>
           </a:p>
           <a:p>
             <a:pPr lvl="2"/>
             <a:r>
-              <a:rPr lang="en-US" smtClean="0"/>
+              <a:rPr lang="en-US"/>
               <a:t>Third level</a:t>
             </a:r>
           </a:p>
           <a:p>
             <a:pPr lvl="3"/>
             <a:r>
-              <a:rPr lang="en-US" smtClean="0"/>
+              <a:rPr lang="en-US"/>
               <a:t>Fourth level</a:t>
             </a:r>
           </a:p>
           <a:p>
             <a:pPr lvl="4"/>
             <a:r>
-              <a:rPr lang="en-US" smtClean="0"/>
+              <a:rPr lang="en-US"/>
               <a:t>Fifth level</a:t>
             </a:r>
-            <a:endParaRPr lang="en-US"/>
           </a:p>
         </p:txBody>
       </p:sp>
@@ -1230,7 +1221,7 @@
           <a:p>
             <a:fld id="{842CD987-D5F0-423A-B571-656612AAA3E1}" type="datetimeFigureOut">
               <a:rPr lang="en-US" smtClean="0"/>
-              <a:t>11/20/2017</a:t>
+              <a:t>1/15/2026</a:t>
             </a:fld>
             <a:endParaRPr lang="en-US"/>
           </a:p>
@@ -1324,10 +1315,9 @@
           <a:lstStyle/>
           <a:p>
             <a:r>
-              <a:rPr lang="en-US" smtClean="0"/>
+              <a:rPr lang="en-US"/>
               <a:t>Click to edit Master title style</a:t>
             </a:r>
-            <a:endParaRPr lang="en-US"/>
           </a:p>
         </p:txBody>
       </p:sp>
@@ -1390,7 +1380,7 @@
           <a:p>
             <a:pPr lvl="0"/>
             <a:r>
-              <a:rPr lang="en-US" smtClean="0"/>
+              <a:rPr lang="en-US"/>
               <a:t>Click to edit Master text styles</a:t>
             </a:r>
           </a:p>
@@ -1418,38 +1408,37 @@
           <a:p>
             <a:pPr lvl="0"/>
             <a:r>
-              <a:rPr lang="en-US" smtClean="0"/>
+              <a:rPr lang="en-US"/>
               <a:t>Click to edit Master text styles</a:t>
             </a:r>
           </a:p>
           <a:p>
             <a:pPr lvl="1"/>
             <a:r>
-              <a:rPr lang="en-US" smtClean="0"/>
+              <a:rPr lang="en-US"/>
               <a:t>Second level</a:t>
             </a:r>
           </a:p>
           <a:p>
             <a:pPr lvl="2"/>
             <a:r>
-              <a:rPr lang="en-US" smtClean="0"/>
+              <a:rPr lang="en-US"/>
               <a:t>Third level</a:t>
             </a:r>
           </a:p>
           <a:p>
             <a:pPr lvl="3"/>
             <a:r>
-              <a:rPr lang="en-US" smtClean="0"/>
+              <a:rPr lang="en-US"/>
               <a:t>Fourth level</a:t>
             </a:r>
           </a:p>
           <a:p>
             <a:pPr lvl="4"/>
             <a:r>
-              <a:rPr lang="en-US" smtClean="0"/>
+              <a:rPr lang="en-US"/>
               <a:t>Fifth level</a:t>
             </a:r>
-            <a:endParaRPr lang="en-US"/>
           </a:p>
         </p:txBody>
       </p:sp>
@@ -1512,7 +1501,7 @@
           <a:p>
             <a:pPr lvl="0"/>
             <a:r>
-              <a:rPr lang="en-US" smtClean="0"/>
+              <a:rPr lang="en-US"/>
               <a:t>Click to edit Master text styles</a:t>
             </a:r>
           </a:p>
@@ -1540,38 +1529,37 @@
           <a:p>
             <a:pPr lvl="0"/>
             <a:r>
-              <a:rPr lang="en-US" smtClean="0"/>
+              <a:rPr lang="en-US"/>
               <a:t>Click to edit Master text styles</a:t>
             </a:r>
           </a:p>
           <a:p>
             <a:pPr lvl="1"/>
             <a:r>
-              <a:rPr lang="en-US" smtClean="0"/>
+              <a:rPr lang="en-US"/>
               <a:t>Second level</a:t>
             </a:r>
           </a:p>
           <a:p>
             <a:pPr lvl="2"/>
             <a:r>
-              <a:rPr lang="en-US" smtClean="0"/>
+              <a:rPr lang="en-US"/>
               <a:t>Third level</a:t>
             </a:r>
           </a:p>
           <a:p>
             <a:pPr lvl="3"/>
             <a:r>
-              <a:rPr lang="en-US" smtClean="0"/>
+              <a:rPr lang="en-US"/>
               <a:t>Fourth level</a:t>
             </a:r>
           </a:p>
           <a:p>
             <a:pPr lvl="4"/>
             <a:r>
-              <a:rPr lang="en-US" smtClean="0"/>
+              <a:rPr lang="en-US"/>
               <a:t>Fifth level</a:t>
             </a:r>
-            <a:endParaRPr lang="en-US"/>
           </a:p>
         </p:txBody>
       </p:sp>
@@ -1592,7 +1580,7 @@
           <a:p>
             <a:fld id="{842CD987-D5F0-423A-B571-656612AAA3E1}" type="datetimeFigureOut">
               <a:rPr lang="en-US" smtClean="0"/>
-              <a:t>11/20/2017</a:t>
+              <a:t>1/15/2026</a:t>
             </a:fld>
             <a:endParaRPr lang="en-US"/>
           </a:p>
@@ -1681,10 +1669,9 @@
           <a:lstStyle/>
           <a:p>
             <a:r>
-              <a:rPr lang="en-US" smtClean="0"/>
+              <a:rPr lang="en-US"/>
               <a:t>Click to edit Master title style</a:t>
             </a:r>
-            <a:endParaRPr lang="en-US"/>
           </a:p>
         </p:txBody>
       </p:sp>
@@ -1705,7 +1692,7 @@
           <a:p>
             <a:fld id="{842CD987-D5F0-423A-B571-656612AAA3E1}" type="datetimeFigureOut">
               <a:rPr lang="en-US" smtClean="0"/>
-              <a:t>11/20/2017</a:t>
+              <a:t>1/15/2026</a:t>
             </a:fld>
             <a:endParaRPr lang="en-US"/>
           </a:p>
@@ -1795,7 +1782,7 @@
           <a:p>
             <a:fld id="{842CD987-D5F0-423A-B571-656612AAA3E1}" type="datetimeFigureOut">
               <a:rPr lang="en-US" smtClean="0"/>
-              <a:t>11/20/2017</a:t>
+              <a:t>1/15/2026</a:t>
             </a:fld>
             <a:endParaRPr lang="en-US"/>
           </a:p>
@@ -1893,10 +1880,9 @@
           </a:lstStyle>
           <a:p>
             <a:r>
-              <a:rPr lang="en-US" smtClean="0"/>
+              <a:rPr lang="en-US"/>
               <a:t>Click to edit Master title style</a:t>
             </a:r>
-            <a:endParaRPr lang="en-US"/>
           </a:p>
         </p:txBody>
       </p:sp>
@@ -1950,38 +1936,37 @@
           <a:p>
             <a:pPr lvl="0"/>
             <a:r>
-              <a:rPr lang="en-US" smtClean="0"/>
+              <a:rPr lang="en-US"/>
               <a:t>Click to edit Master text styles</a:t>
             </a:r>
           </a:p>
           <a:p>
             <a:pPr lvl="1"/>
             <a:r>
-              <a:rPr lang="en-US" smtClean="0"/>
+              <a:rPr lang="en-US"/>
               <a:t>Second level</a:t>
             </a:r>
           </a:p>
           <a:p>
             <a:pPr lvl="2"/>
             <a:r>
-              <a:rPr lang="en-US" smtClean="0"/>
+              <a:rPr lang="en-US"/>
               <a:t>Third level</a:t>
             </a:r>
           </a:p>
           <a:p>
             <a:pPr lvl="3"/>
             <a:r>
-              <a:rPr lang="en-US" smtClean="0"/>
+              <a:rPr lang="en-US"/>
               <a:t>Fourth level</a:t>
             </a:r>
           </a:p>
           <a:p>
             <a:pPr lvl="4"/>
             <a:r>
-              <a:rPr lang="en-US" smtClean="0"/>
+              <a:rPr lang="en-US"/>
               <a:t>Fifth level</a:t>
             </a:r>
-            <a:endParaRPr lang="en-US"/>
           </a:p>
         </p:txBody>
       </p:sp>
@@ -2044,7 +2029,7 @@
           <a:p>
             <a:pPr lvl="0"/>
             <a:r>
-              <a:rPr lang="en-US" smtClean="0"/>
+              <a:rPr lang="en-US"/>
               <a:t>Click to edit Master text styles</a:t>
             </a:r>
           </a:p>
@@ -2067,7 +2052,7 @@
           <a:p>
             <a:fld id="{842CD987-D5F0-423A-B571-656612AAA3E1}" type="datetimeFigureOut">
               <a:rPr lang="en-US" smtClean="0"/>
-              <a:t>11/20/2017</a:t>
+              <a:t>1/15/2026</a:t>
             </a:fld>
             <a:endParaRPr lang="en-US"/>
           </a:p>
@@ -2165,10 +2150,9 @@
           </a:lstStyle>
           <a:p>
             <a:r>
-              <a:rPr lang="en-US" smtClean="0"/>
+              <a:rPr lang="en-US"/>
               <a:t>Click to edit Master title style</a:t>
             </a:r>
-            <a:endParaRPr lang="en-US"/>
           </a:p>
         </p:txBody>
       </p:sp>
@@ -2292,7 +2276,7 @@
           <a:p>
             <a:pPr lvl="0"/>
             <a:r>
-              <a:rPr lang="en-US" smtClean="0"/>
+              <a:rPr lang="en-US"/>
               <a:t>Click to edit Master text styles</a:t>
             </a:r>
           </a:p>
@@ -2315,7 +2299,7 @@
           <a:p>
             <a:fld id="{842CD987-D5F0-423A-B571-656612AAA3E1}" type="datetimeFigureOut">
               <a:rPr lang="en-US" smtClean="0"/>
-              <a:t>11/20/2017</a:t>
+              <a:t>1/15/2026</a:t>
             </a:fld>
             <a:endParaRPr lang="en-US"/>
           </a:p>
@@ -2337,7 +2321,7 @@
           <a:lstStyle/>
           <a:p>
             <a:r>
-              <a:rPr lang="en-US" smtClean="0"/>
+              <a:rPr lang="en-US"/>
               <a:t>
               </a:t>
             </a:r>
@@ -2424,10 +2408,9 @@
           <a:lstStyle/>
           <a:p>
             <a:r>
-              <a:rPr lang="en-US" smtClean="0"/>
+              <a:rPr lang="en-US"/>
               <a:t>Click to edit Master title style</a:t>
             </a:r>
-            <a:endParaRPr lang="en-US"/>
           </a:p>
         </p:txBody>
       </p:sp>
@@ -2458,38 +2441,37 @@
           <a:p>
             <a:pPr lvl="0"/>
             <a:r>
-              <a:rPr lang="en-US" smtClean="0"/>
+              <a:rPr lang="en-US"/>
               <a:t>Click to edit Master text styles</a:t>
             </a:r>
           </a:p>
           <a:p>
             <a:pPr lvl="1"/>
             <a:r>
-              <a:rPr lang="en-US" smtClean="0"/>
+              <a:rPr lang="en-US"/>
               <a:t>Second level</a:t>
             </a:r>
           </a:p>
           <a:p>
             <a:pPr lvl="2"/>
             <a:r>
-              <a:rPr lang="en-US" smtClean="0"/>
+              <a:rPr lang="en-US"/>
               <a:t>Third level</a:t>
             </a:r>
           </a:p>
           <a:p>
             <a:pPr lvl="3"/>
             <a:r>
-              <a:rPr lang="en-US" smtClean="0"/>
+              <a:rPr lang="en-US"/>
               <a:t>Fourth level</a:t>
             </a:r>
           </a:p>
           <a:p>
             <a:pPr lvl="4"/>
             <a:r>
-              <a:rPr lang="en-US" smtClean="0"/>
+              <a:rPr lang="en-US"/>
               <a:t>Fifth level</a:t>
             </a:r>
-            <a:endParaRPr lang="en-US"/>
           </a:p>
         </p:txBody>
       </p:sp>
@@ -2528,7 +2510,7 @@
           <a:p>
             <a:fld id="{842CD987-D5F0-423A-B571-656612AAA3E1}" type="datetimeFigureOut">
               <a:rPr lang="en-US" smtClean="0"/>
-              <a:t>11/20/2017</a:t>
+              <a:t>1/15/2026</a:t>
             </a:fld>
             <a:endParaRPr lang="en-US"/>
           </a:p>
@@ -3740,8 +3722,8 @@
         </p:nvSpPr>
         <p:spPr>
           <a:xfrm>
-            <a:off x="797062" y="921140"/>
-            <a:ext cx="3600400" cy="1200329"/>
+            <a:off x="755576" y="908720"/>
+            <a:ext cx="7812868" cy="1200329"/>
           </a:xfrm>
           <a:prstGeom prst="rect">
             <a:avLst/>
@@ -3755,26 +3737,34 @@
           <a:lstStyle/>
           <a:p>
             <a:r>
-              <a:rPr lang="en-US" sz="3600" dirty="0" smtClean="0">
+              <a:rPr lang="en-US" sz="3600" dirty="0">
                 <a:latin typeface="UT Sans Bold" pitchFamily="50" charset="0"/>
               </a:rPr>
-              <a:t>TITLUL</a:t>
-            </a:r>
-          </a:p>
-          <a:p>
-            <a:r>
-              <a:rPr lang="en-US" sz="3600" dirty="0" smtClean="0">
+              <a:t>NIBIRU</a:t>
+            </a:r>
+          </a:p>
+          <a:p>
+            <a:r>
+              <a:rPr lang="en-US" sz="3600" dirty="0" err="1">
                 <a:latin typeface="UT Sans Bold" pitchFamily="50" charset="0"/>
               </a:rPr>
-              <a:t>LUCR</a:t>
-            </a:r>
-            <a:r>
-              <a:rPr lang="ro-RO" sz="3600" dirty="0" smtClean="0">
+              <a:t>Osciloscop</a:t>
+            </a:r>
+            <a:r>
+              <a:rPr lang="en-US" sz="3600" dirty="0">
                 <a:latin typeface="UT Sans Bold" pitchFamily="50" charset="0"/>
               </a:rPr>
-              <a:t>ĂRII</a:t>
-            </a:r>
-            <a:endParaRPr lang="en-US" dirty="0"/>
+              <a:t> Digital</a:t>
+            </a:r>
+            <a:r>
+              <a:rPr lang="ro-RO" sz="3600" dirty="0">
+                <a:latin typeface="UT Sans Bold" pitchFamily="50" charset="0"/>
+              </a:rPr>
+              <a:t> cu Izolație Galvanică</a:t>
+            </a:r>
+            <a:endParaRPr lang="en-US" sz="3600" dirty="0">
+              <a:latin typeface="UT Sans Bold" pitchFamily="50" charset="0"/>
+            </a:endParaRPr>
           </a:p>
         </p:txBody>
       </p:sp>
@@ -3786,8 +3776,8 @@
         </p:nvSpPr>
         <p:spPr>
           <a:xfrm>
-            <a:off x="863588" y="2515939"/>
-            <a:ext cx="3600400" cy="461665"/>
+            <a:off x="755576" y="3193604"/>
+            <a:ext cx="3600400" cy="830997"/>
           </a:xfrm>
           <a:prstGeom prst="rect">
             <a:avLst/>
@@ -3801,10 +3791,27 @@
           <a:lstStyle/>
           <a:p>
             <a:r>
-              <a:rPr lang="ro-RO" sz="2400" dirty="0" smtClean="0">
+              <a:rPr lang="en-US" sz="2400" dirty="0" err="1">
                 <a:latin typeface="UT Sans Bold" pitchFamily="50" charset="0"/>
               </a:rPr>
-              <a:t>Nume Prenume</a:t>
+              <a:t>Furtun</a:t>
+            </a:r>
+            <a:r>
+              <a:rPr lang="ro-RO" sz="2400" dirty="0">
+                <a:latin typeface="UT Sans Bold" pitchFamily="50" charset="0"/>
+              </a:rPr>
+              <a:t>ă Cristian</a:t>
+            </a:r>
+            <a:br>
+              <a:rPr lang="ro-RO" sz="2400" dirty="0">
+                <a:latin typeface="UT Sans Bold" pitchFamily="50" charset="0"/>
+              </a:rPr>
+            </a:br>
+            <a:r>
+              <a:rPr lang="ro-RO" sz="2400" dirty="0">
+                <a:latin typeface="UT Sans Bold" pitchFamily="50" charset="0"/>
+              </a:rPr>
+              <a:t>Iordache Denis</a:t>
             </a:r>
             <a:endParaRPr lang="en-US" sz="1200" dirty="0"/>
           </a:p>
@@ -3820,13 +3827,6 @@
   <p:clrMapOvr>
     <a:masterClrMapping/>
   </p:clrMapOvr>
-  <p:timing>
-    <p:tnLst>
-      <p:par>
-        <p:cTn id="1" dur="indefinite" restart="never" nodeType="tmRoot"/>
-      </p:par>
-    </p:tnLst>
-  </p:timing>
 </p:sld>
 </file>
 
@@ -3978,716 +3978,6 @@
           </p:txBody>
         </p:sp>
       </p:grpSp>
-      <p:sp>
-        <p:nvSpPr>
-          <p:cNvPr id="7" name="TextBox 6"/>
-          <p:cNvSpPr txBox="1"/>
-          <p:nvPr/>
-        </p:nvSpPr>
-        <p:spPr>
-          <a:xfrm>
-            <a:off x="611560" y="1044019"/>
-            <a:ext cx="7848872" cy="4401205"/>
-          </a:xfrm>
-          <a:prstGeom prst="rect">
-            <a:avLst/>
-          </a:prstGeom>
-          <a:noFill/>
-        </p:spPr>
-        <p:txBody>
-          <a:bodyPr wrap="square" rtlCol="0">
-            <a:spAutoFit/>
-          </a:bodyPr>
-          <a:lstStyle/>
-          <a:p>
-            <a:pPr marL="342900" indent="-342900" algn="just">
-              <a:buBlip>
-                <a:blip r:embed="rId2"/>
-              </a:buBlip>
-            </a:pPr>
-            <a:r>
-              <a:rPr lang="en-US" sz="2000" dirty="0">
-                <a:latin typeface="UT Sans" pitchFamily="50" charset="0"/>
-              </a:rPr>
-              <a:t>Lorem ipsum dolor sit </a:t>
-            </a:r>
-            <a:r>
-              <a:rPr lang="en-US" sz="2000" dirty="0" err="1">
-                <a:latin typeface="UT Sans" pitchFamily="50" charset="0"/>
-              </a:rPr>
-              <a:t>amet</a:t>
-            </a:r>
-            <a:r>
-              <a:rPr lang="en-US" sz="2000" dirty="0">
-                <a:latin typeface="UT Sans" pitchFamily="50" charset="0"/>
-              </a:rPr>
-              <a:t>, </a:t>
-            </a:r>
-            <a:r>
-              <a:rPr lang="en-US" sz="2000" dirty="0" err="1">
-                <a:latin typeface="UT Sans" pitchFamily="50" charset="0"/>
-              </a:rPr>
-              <a:t>consectetur</a:t>
-            </a:r>
-            <a:r>
-              <a:rPr lang="en-US" sz="2000" dirty="0">
-                <a:latin typeface="UT Sans" pitchFamily="50" charset="0"/>
-              </a:rPr>
-              <a:t> </a:t>
-            </a:r>
-            <a:r>
-              <a:rPr lang="en-US" sz="2000" dirty="0" err="1">
-                <a:latin typeface="UT Sans" pitchFamily="50" charset="0"/>
-              </a:rPr>
-              <a:t>adipiscing</a:t>
-            </a:r>
-            <a:r>
-              <a:rPr lang="en-US" sz="2000" dirty="0">
-                <a:latin typeface="UT Sans" pitchFamily="50" charset="0"/>
-              </a:rPr>
-              <a:t> </a:t>
-            </a:r>
-            <a:r>
-              <a:rPr lang="en-US" sz="2000" dirty="0" err="1">
-                <a:latin typeface="UT Sans" pitchFamily="50" charset="0"/>
-              </a:rPr>
-              <a:t>elit</a:t>
-            </a:r>
-            <a:r>
-              <a:rPr lang="en-US" sz="2000" dirty="0">
-                <a:latin typeface="UT Sans" pitchFamily="50" charset="0"/>
-              </a:rPr>
-              <a:t>. </a:t>
-            </a:r>
-            <a:r>
-              <a:rPr lang="en-US" sz="2000" dirty="0" err="1">
-                <a:latin typeface="UT Sans" pitchFamily="50" charset="0"/>
-              </a:rPr>
-              <a:t>Nulla</a:t>
-            </a:r>
-            <a:r>
-              <a:rPr lang="en-US" sz="2000" dirty="0">
-                <a:latin typeface="UT Sans" pitchFamily="50" charset="0"/>
-              </a:rPr>
-              <a:t> </a:t>
-            </a:r>
-            <a:r>
-              <a:rPr lang="en-US" sz="2000" dirty="0" err="1">
-                <a:latin typeface="UT Sans" pitchFamily="50" charset="0"/>
-              </a:rPr>
-              <a:t>massa</a:t>
-            </a:r>
-            <a:r>
-              <a:rPr lang="en-US" sz="2000" dirty="0">
-                <a:latin typeface="UT Sans" pitchFamily="50" charset="0"/>
-              </a:rPr>
-              <a:t> </a:t>
-            </a:r>
-            <a:r>
-              <a:rPr lang="en-US" sz="2000" dirty="0" err="1">
-                <a:latin typeface="UT Sans" pitchFamily="50" charset="0"/>
-              </a:rPr>
-              <a:t>nulla</a:t>
-            </a:r>
-            <a:r>
-              <a:rPr lang="en-US" sz="2000" dirty="0">
-                <a:latin typeface="UT Sans" pitchFamily="50" charset="0"/>
-              </a:rPr>
-              <a:t> Lorem ipsum dolor </a:t>
-            </a:r>
-            <a:endParaRPr lang="en-US" sz="2000" dirty="0" smtClean="0">
-              <a:latin typeface="UT Sans" pitchFamily="50" charset="0"/>
-            </a:endParaRPr>
-          </a:p>
-          <a:p>
-            <a:pPr marL="800100" lvl="1" indent="-342900" algn="just">
-              <a:buFont typeface=".AppleSystemUIFont" charset="-120"/>
-              <a:buChar char="-"/>
-            </a:pPr>
-            <a:r>
-              <a:rPr lang="en-US" sz="2000" dirty="0">
-                <a:latin typeface="UT Sans" pitchFamily="50" charset="0"/>
-              </a:rPr>
-              <a:t>Lorem ipsum dolor </a:t>
-            </a:r>
-            <a:endParaRPr lang="en-US" sz="2000" dirty="0" smtClean="0">
-              <a:latin typeface="UT Sans" pitchFamily="50" charset="0"/>
-            </a:endParaRPr>
-          </a:p>
-          <a:p>
-            <a:pPr marL="1257300" lvl="2" indent="-342900" algn="just">
-              <a:buFont typeface="Wingdings" charset="2"/>
-              <a:buChar char="§"/>
-            </a:pPr>
-            <a:r>
-              <a:rPr lang="en-US" sz="2000" dirty="0">
-                <a:latin typeface="UT Sans" pitchFamily="50" charset="0"/>
-              </a:rPr>
-              <a:t>Lorem ipsum dolor</a:t>
-            </a:r>
-            <a:endParaRPr lang="en-US" sz="2000" dirty="0" smtClean="0">
-              <a:latin typeface="UT Sans" pitchFamily="50" charset="0"/>
-            </a:endParaRPr>
-          </a:p>
-          <a:p>
-            <a:pPr algn="just"/>
-            <a:endParaRPr lang="ro-RO" sz="2000" dirty="0" smtClean="0">
-              <a:latin typeface="UT Symbols" charset="0"/>
-              <a:ea typeface="UT Symbols" charset="0"/>
-              <a:cs typeface="UT Symbols" charset="0"/>
-            </a:endParaRPr>
-          </a:p>
-          <a:p>
-            <a:pPr marL="342900" indent="-342900" algn="just">
-              <a:buBlip>
-                <a:blip r:embed="rId2"/>
-              </a:buBlip>
-            </a:pPr>
-            <a:r>
-              <a:rPr lang="en-US" sz="2000" dirty="0" smtClean="0">
-                <a:latin typeface="UT Sans" pitchFamily="50" charset="0"/>
-              </a:rPr>
-              <a:t>Nam </a:t>
-            </a:r>
-            <a:r>
-              <a:rPr lang="en-US" sz="2000" dirty="0" err="1">
-                <a:latin typeface="UT Sans" pitchFamily="50" charset="0"/>
-              </a:rPr>
-              <a:t>pellentesque</a:t>
-            </a:r>
-            <a:r>
-              <a:rPr lang="en-US" sz="2000" dirty="0">
-                <a:latin typeface="UT Sans" pitchFamily="50" charset="0"/>
-              </a:rPr>
-              <a:t>, </a:t>
-            </a:r>
-            <a:r>
-              <a:rPr lang="en-US" sz="2000" dirty="0" err="1">
-                <a:latin typeface="UT Sans" pitchFamily="50" charset="0"/>
-              </a:rPr>
-              <a:t>nulla</a:t>
-            </a:r>
-            <a:r>
-              <a:rPr lang="en-US" sz="2000" dirty="0">
-                <a:latin typeface="UT Sans" pitchFamily="50" charset="0"/>
-              </a:rPr>
-              <a:t> a </a:t>
-            </a:r>
-            <a:r>
-              <a:rPr lang="en-US" sz="2000" dirty="0" err="1">
-                <a:latin typeface="UT Sans" pitchFamily="50" charset="0"/>
-              </a:rPr>
-              <a:t>feugiat</a:t>
-            </a:r>
-            <a:r>
-              <a:rPr lang="en-US" sz="2000" dirty="0">
-                <a:latin typeface="UT Sans" pitchFamily="50" charset="0"/>
-              </a:rPr>
-              <a:t> </a:t>
-            </a:r>
-            <a:r>
-              <a:rPr lang="en-US" sz="2000" dirty="0" err="1">
-                <a:latin typeface="UT Sans" pitchFamily="50" charset="0"/>
-              </a:rPr>
-              <a:t>condimentum</a:t>
-            </a:r>
-            <a:r>
-              <a:rPr lang="en-US" sz="2000" dirty="0">
-                <a:latin typeface="UT Sans" pitchFamily="50" charset="0"/>
-              </a:rPr>
-              <a:t>, </a:t>
-            </a:r>
-            <a:r>
-              <a:rPr lang="en-US" sz="2000" dirty="0" err="1">
-                <a:latin typeface="UT Sans" pitchFamily="50" charset="0"/>
-              </a:rPr>
-              <a:t>erat</a:t>
-            </a:r>
-            <a:r>
-              <a:rPr lang="en-US" sz="2000" dirty="0">
-                <a:latin typeface="UT Sans" pitchFamily="50" charset="0"/>
-              </a:rPr>
-              <a:t> </a:t>
-            </a:r>
-            <a:r>
-              <a:rPr lang="en-US" sz="2000" dirty="0" err="1">
-                <a:latin typeface="UT Sans" pitchFamily="50" charset="0"/>
-              </a:rPr>
-              <a:t>lectus</a:t>
-            </a:r>
-            <a:r>
-              <a:rPr lang="en-US" sz="2000" dirty="0">
-                <a:latin typeface="UT Sans" pitchFamily="50" charset="0"/>
-              </a:rPr>
-              <a:t> </a:t>
-            </a:r>
-            <a:r>
-              <a:rPr lang="en-US" sz="2000" dirty="0" err="1">
-                <a:latin typeface="UT Sans" pitchFamily="50" charset="0"/>
-              </a:rPr>
-              <a:t>vulputate</a:t>
-            </a:r>
-            <a:r>
-              <a:rPr lang="en-US" sz="2000" dirty="0">
-                <a:latin typeface="UT Sans" pitchFamily="50" charset="0"/>
-              </a:rPr>
-              <a:t> magna, Lorem ipsum dolor ac </a:t>
-            </a:r>
-            <a:r>
-              <a:rPr lang="en-US" sz="2000" dirty="0" err="1">
-                <a:latin typeface="UT Sans" pitchFamily="50" charset="0"/>
-              </a:rPr>
-              <a:t>sollicitudin</a:t>
-            </a:r>
-            <a:r>
-              <a:rPr lang="en-US" sz="2000" dirty="0">
-                <a:latin typeface="UT Sans" pitchFamily="50" charset="0"/>
-              </a:rPr>
-              <a:t>. </a:t>
-            </a:r>
-            <a:r>
-              <a:rPr lang="en-US" sz="2000" dirty="0" err="1">
-                <a:latin typeface="UT Sans" pitchFamily="50" charset="0"/>
-              </a:rPr>
-              <a:t>Morbi</a:t>
-            </a:r>
-            <a:r>
-              <a:rPr lang="en-US" sz="2000" dirty="0">
-                <a:latin typeface="UT Sans" pitchFamily="50" charset="0"/>
-              </a:rPr>
-              <a:t> </a:t>
-            </a:r>
-            <a:r>
-              <a:rPr lang="en-US" sz="2000" dirty="0" err="1">
-                <a:latin typeface="UT Sans" pitchFamily="50" charset="0"/>
-              </a:rPr>
-              <a:t>blandit</a:t>
-            </a:r>
-            <a:r>
-              <a:rPr lang="en-US" sz="2000" dirty="0">
-                <a:latin typeface="UT Sans" pitchFamily="50" charset="0"/>
-              </a:rPr>
-              <a:t> </a:t>
-            </a:r>
-            <a:r>
-              <a:rPr lang="en-US" sz="2000" dirty="0" err="1">
-                <a:latin typeface="UT Sans" pitchFamily="50" charset="0"/>
-              </a:rPr>
-              <a:t>posuere</a:t>
-            </a:r>
-            <a:r>
-              <a:rPr lang="en-US" sz="2000" dirty="0">
-                <a:latin typeface="UT Sans" pitchFamily="50" charset="0"/>
-              </a:rPr>
-              <a:t> </a:t>
-            </a:r>
-            <a:r>
-              <a:rPr lang="en-US" sz="2000" dirty="0" err="1">
-                <a:latin typeface="UT Sans" pitchFamily="50" charset="0"/>
-              </a:rPr>
-              <a:t>facilisis</a:t>
-            </a:r>
-            <a:r>
-              <a:rPr lang="en-US" sz="2000" dirty="0" smtClean="0">
-                <a:latin typeface="UT Sans" pitchFamily="50" charset="0"/>
-              </a:rPr>
-              <a:t>.</a:t>
-            </a:r>
-            <a:endParaRPr lang="ro-RO" sz="2000" dirty="0" smtClean="0">
-              <a:latin typeface="UT Sans" pitchFamily="50" charset="0"/>
-            </a:endParaRPr>
-          </a:p>
-          <a:p>
-            <a:pPr marL="342900" indent="-342900" algn="just">
-              <a:buBlip>
-                <a:blip r:embed="rId2"/>
-              </a:buBlip>
-            </a:pPr>
-            <a:endParaRPr lang="ro-RO" sz="2000" dirty="0">
-              <a:latin typeface="UT Sans" pitchFamily="50" charset="0"/>
-            </a:endParaRPr>
-          </a:p>
-          <a:p>
-            <a:pPr marL="342900" indent="-342900" algn="just">
-              <a:buBlip>
-                <a:blip r:embed="rId2"/>
-              </a:buBlip>
-            </a:pPr>
-            <a:r>
-              <a:rPr lang="en-US" sz="2000" dirty="0" err="1">
-                <a:latin typeface="UT Sans" pitchFamily="50" charset="0"/>
-              </a:rPr>
-              <a:t>Cras</a:t>
-            </a:r>
-            <a:r>
-              <a:rPr lang="en-US" sz="2000" dirty="0">
-                <a:latin typeface="UT Sans" pitchFamily="50" charset="0"/>
-              </a:rPr>
-              <a:t> dictum dui a </a:t>
-            </a:r>
-            <a:r>
-              <a:rPr lang="en-US" sz="2000" dirty="0" err="1">
-                <a:latin typeface="UT Sans" pitchFamily="50" charset="0"/>
-              </a:rPr>
-              <a:t>consectetur</a:t>
-            </a:r>
-            <a:r>
-              <a:rPr lang="en-US" sz="2000" dirty="0">
-                <a:latin typeface="UT Sans" pitchFamily="50" charset="0"/>
-              </a:rPr>
-              <a:t> </a:t>
-            </a:r>
-            <a:r>
-              <a:rPr lang="en-US" sz="2000" dirty="0" err="1">
-                <a:latin typeface="UT Sans" pitchFamily="50" charset="0"/>
-              </a:rPr>
-              <a:t>sodales</a:t>
-            </a:r>
-            <a:r>
-              <a:rPr lang="en-US" sz="2000" dirty="0">
-                <a:latin typeface="UT Sans" pitchFamily="50" charset="0"/>
-              </a:rPr>
-              <a:t>. </a:t>
-            </a:r>
-            <a:r>
-              <a:rPr lang="en-US" sz="2000" dirty="0" err="1">
-                <a:latin typeface="UT Sans" pitchFamily="50" charset="0"/>
-              </a:rPr>
-              <a:t>Curabitur</a:t>
-            </a:r>
-            <a:r>
-              <a:rPr lang="en-US" sz="2000" dirty="0">
-                <a:latin typeface="UT Sans" pitchFamily="50" charset="0"/>
-              </a:rPr>
-              <a:t> </a:t>
-            </a:r>
-            <a:r>
-              <a:rPr lang="en-US" sz="2000" dirty="0" err="1">
-                <a:latin typeface="UT Sans" pitchFamily="50" charset="0"/>
-              </a:rPr>
-              <a:t>feugiat</a:t>
-            </a:r>
-            <a:r>
-              <a:rPr lang="en-US" sz="2000" dirty="0">
-                <a:latin typeface="UT Sans" pitchFamily="50" charset="0"/>
-              </a:rPr>
-              <a:t> </a:t>
-            </a:r>
-            <a:r>
-              <a:rPr lang="en-US" sz="2000" dirty="0" err="1">
-                <a:latin typeface="UT Sans" pitchFamily="50" charset="0"/>
-              </a:rPr>
-              <a:t>nulla</a:t>
-            </a:r>
-            <a:r>
-              <a:rPr lang="en-US" sz="2000" dirty="0">
-                <a:latin typeface="UT Sans" pitchFamily="50" charset="0"/>
-              </a:rPr>
-              <a:t> at </a:t>
-            </a:r>
-            <a:r>
-              <a:rPr lang="en-US" sz="2000" dirty="0" err="1">
-                <a:latin typeface="UT Sans" pitchFamily="50" charset="0"/>
-              </a:rPr>
-              <a:t>bibendum</a:t>
-            </a:r>
-            <a:r>
-              <a:rPr lang="en-US" sz="2000" dirty="0">
-                <a:latin typeface="UT Sans" pitchFamily="50" charset="0"/>
-              </a:rPr>
-              <a:t> </a:t>
-            </a:r>
-            <a:r>
-              <a:rPr lang="en-US" sz="2000" dirty="0" err="1">
-                <a:latin typeface="UT Sans" pitchFamily="50" charset="0"/>
-              </a:rPr>
-              <a:t>consequat</a:t>
-            </a:r>
-            <a:r>
-              <a:rPr lang="en-US" sz="2000" dirty="0">
-                <a:latin typeface="UT Sans" pitchFamily="50" charset="0"/>
-              </a:rPr>
-              <a:t>. </a:t>
-            </a:r>
-            <a:r>
-              <a:rPr lang="en-US" sz="2000" dirty="0" err="1">
-                <a:latin typeface="UT Sans" pitchFamily="50" charset="0"/>
-              </a:rPr>
-              <a:t>Proin</a:t>
-            </a:r>
-            <a:r>
-              <a:rPr lang="en-US" sz="2000" dirty="0">
-                <a:latin typeface="UT Sans" pitchFamily="50" charset="0"/>
-              </a:rPr>
-              <a:t> </a:t>
-            </a:r>
-            <a:r>
-              <a:rPr lang="en-US" sz="2000" dirty="0" err="1">
-                <a:latin typeface="UT Sans" pitchFamily="50" charset="0"/>
-              </a:rPr>
-              <a:t>egestas</a:t>
-            </a:r>
-            <a:r>
-              <a:rPr lang="en-US" sz="2000" dirty="0">
-                <a:latin typeface="UT Sans" pitchFamily="50" charset="0"/>
-              </a:rPr>
-              <a:t> </a:t>
-            </a:r>
-            <a:r>
-              <a:rPr lang="en-US" sz="2000" dirty="0" err="1">
-                <a:latin typeface="UT Sans" pitchFamily="50" charset="0"/>
-              </a:rPr>
-              <a:t>est</a:t>
-            </a:r>
-            <a:r>
-              <a:rPr lang="en-US" sz="2000" dirty="0">
-                <a:latin typeface="UT Sans" pitchFamily="50" charset="0"/>
-              </a:rPr>
-              <a:t> a </a:t>
-            </a:r>
-            <a:r>
-              <a:rPr lang="en-US" sz="2000" dirty="0" err="1">
-                <a:latin typeface="UT Sans" pitchFamily="50" charset="0"/>
-              </a:rPr>
-              <a:t>tellus</a:t>
-            </a:r>
-            <a:r>
-              <a:rPr lang="en-US" sz="2000" dirty="0">
-                <a:latin typeface="UT Sans" pitchFamily="50" charset="0"/>
-              </a:rPr>
-              <a:t> </a:t>
-            </a:r>
-            <a:r>
-              <a:rPr lang="en-US" sz="2000" dirty="0" err="1">
-                <a:latin typeface="UT Sans" pitchFamily="50" charset="0"/>
-              </a:rPr>
-              <a:t>tincidunt</a:t>
-            </a:r>
-            <a:r>
-              <a:rPr lang="en-US" sz="2000" dirty="0">
-                <a:latin typeface="UT Sans" pitchFamily="50" charset="0"/>
-              </a:rPr>
-              <a:t>, </a:t>
-            </a:r>
-            <a:r>
-              <a:rPr lang="en-US" sz="2000" dirty="0" err="1">
-                <a:latin typeface="UT Sans" pitchFamily="50" charset="0"/>
-              </a:rPr>
-              <a:t>sed</a:t>
-            </a:r>
-            <a:r>
-              <a:rPr lang="en-US" sz="2000" dirty="0">
-                <a:latin typeface="UT Sans" pitchFamily="50" charset="0"/>
-              </a:rPr>
-              <a:t> </a:t>
-            </a:r>
-            <a:r>
-              <a:rPr lang="en-US" sz="2000" dirty="0" err="1">
-                <a:latin typeface="UT Sans" pitchFamily="50" charset="0"/>
-              </a:rPr>
-              <a:t>tincidunt</a:t>
-            </a:r>
-            <a:r>
-              <a:rPr lang="en-US" sz="2000" dirty="0">
-                <a:latin typeface="UT Sans" pitchFamily="50" charset="0"/>
-              </a:rPr>
-              <a:t> dolor </a:t>
-            </a:r>
-            <a:r>
-              <a:rPr lang="en-US" sz="2000" dirty="0" err="1">
-                <a:latin typeface="UT Sans" pitchFamily="50" charset="0"/>
-              </a:rPr>
-              <a:t>laoreet</a:t>
-            </a:r>
-            <a:r>
-              <a:rPr lang="en-US" sz="2000" dirty="0">
-                <a:latin typeface="UT Sans" pitchFamily="50" charset="0"/>
-              </a:rPr>
-              <a:t>. </a:t>
-            </a:r>
-            <a:r>
-              <a:rPr lang="en-US" sz="2000" dirty="0" err="1">
-                <a:latin typeface="UT Sans" pitchFamily="50" charset="0"/>
-              </a:rPr>
-              <a:t>Fusce</a:t>
-            </a:r>
-            <a:r>
-              <a:rPr lang="en-US" sz="2000" dirty="0">
-                <a:latin typeface="UT Sans" pitchFamily="50" charset="0"/>
-              </a:rPr>
-              <a:t> id </a:t>
-            </a:r>
-            <a:r>
-              <a:rPr lang="en-US" sz="2000" dirty="0" err="1">
-                <a:latin typeface="UT Sans" pitchFamily="50" charset="0"/>
-              </a:rPr>
-              <a:t>augue</a:t>
-            </a:r>
-            <a:r>
-              <a:rPr lang="en-US" sz="2000" dirty="0">
-                <a:latin typeface="UT Sans" pitchFamily="50" charset="0"/>
-              </a:rPr>
-              <a:t> </a:t>
-            </a:r>
-            <a:r>
-              <a:rPr lang="en-US" sz="2000" dirty="0" err="1">
-                <a:latin typeface="UT Sans" pitchFamily="50" charset="0"/>
-              </a:rPr>
-              <a:t>augue</a:t>
-            </a:r>
-            <a:r>
-              <a:rPr lang="en-US" sz="2000" dirty="0">
-                <a:latin typeface="UT Sans" pitchFamily="50" charset="0"/>
-              </a:rPr>
-              <a:t>. Maecenas </a:t>
-            </a:r>
-            <a:r>
-              <a:rPr lang="en-US" sz="2000" dirty="0" err="1">
-                <a:latin typeface="UT Sans" pitchFamily="50" charset="0"/>
-              </a:rPr>
-              <a:t>eget</a:t>
-            </a:r>
-            <a:r>
-              <a:rPr lang="en-US" sz="2000" dirty="0">
-                <a:latin typeface="UT Sans" pitchFamily="50" charset="0"/>
-              </a:rPr>
-              <a:t> </a:t>
-            </a:r>
-            <a:r>
-              <a:rPr lang="en-US" sz="2000" dirty="0" err="1">
-                <a:latin typeface="UT Sans" pitchFamily="50" charset="0"/>
-              </a:rPr>
-              <a:t>purus</a:t>
-            </a:r>
-            <a:r>
-              <a:rPr lang="en-US" sz="2000" dirty="0">
-                <a:latin typeface="UT Sans" pitchFamily="50" charset="0"/>
-              </a:rPr>
-              <a:t> </a:t>
-            </a:r>
-            <a:r>
-              <a:rPr lang="en-US" sz="2000" dirty="0" err="1">
-                <a:latin typeface="UT Sans" pitchFamily="50" charset="0"/>
-              </a:rPr>
-              <a:t>orci</a:t>
-            </a:r>
-            <a:r>
-              <a:rPr lang="en-US" sz="2000" dirty="0">
-                <a:latin typeface="UT Sans" pitchFamily="50" charset="0"/>
-              </a:rPr>
-              <a:t>. </a:t>
-            </a:r>
-            <a:r>
-              <a:rPr lang="en-US" sz="2000" dirty="0" err="1">
-                <a:latin typeface="UT Sans" pitchFamily="50" charset="0"/>
-              </a:rPr>
-              <a:t>Donec</a:t>
-            </a:r>
-            <a:r>
-              <a:rPr lang="en-US" sz="2000" dirty="0">
-                <a:latin typeface="UT Sans" pitchFamily="50" charset="0"/>
-              </a:rPr>
-              <a:t> tempus </a:t>
-            </a:r>
-            <a:r>
-              <a:rPr lang="en-US" sz="2000" dirty="0" err="1">
-                <a:latin typeface="UT Sans" pitchFamily="50" charset="0"/>
-              </a:rPr>
-              <a:t>aliquet</a:t>
-            </a:r>
-            <a:r>
-              <a:rPr lang="en-US" sz="2000" dirty="0">
-                <a:latin typeface="UT Sans" pitchFamily="50" charset="0"/>
-              </a:rPr>
-              <a:t> gravida. Nam </a:t>
-            </a:r>
-            <a:r>
-              <a:rPr lang="en-US" sz="2000" dirty="0" err="1">
-                <a:latin typeface="UT Sans" pitchFamily="50" charset="0"/>
-              </a:rPr>
-              <a:t>tortor</a:t>
-            </a:r>
-            <a:r>
-              <a:rPr lang="en-US" sz="2000" dirty="0">
-                <a:latin typeface="UT Sans" pitchFamily="50" charset="0"/>
-              </a:rPr>
-              <a:t> </a:t>
-            </a:r>
-            <a:r>
-              <a:rPr lang="en-US" sz="2000" dirty="0" err="1">
-                <a:latin typeface="UT Sans" pitchFamily="50" charset="0"/>
-              </a:rPr>
-              <a:t>elit</a:t>
-            </a:r>
-            <a:r>
-              <a:rPr lang="en-US" sz="2000" dirty="0">
-                <a:latin typeface="UT Sans" pitchFamily="50" charset="0"/>
-              </a:rPr>
-              <a:t>, </a:t>
-            </a:r>
-            <a:r>
-              <a:rPr lang="en-US" sz="2000" dirty="0" err="1">
-                <a:latin typeface="UT Sans" pitchFamily="50" charset="0"/>
-              </a:rPr>
-              <a:t>blandit</a:t>
-            </a:r>
-            <a:r>
-              <a:rPr lang="en-US" sz="2000" dirty="0">
-                <a:latin typeface="UT Sans" pitchFamily="50" charset="0"/>
-              </a:rPr>
-              <a:t> sit </a:t>
-            </a:r>
-            <a:r>
-              <a:rPr lang="en-US" sz="2000" dirty="0" err="1">
-                <a:latin typeface="UT Sans" pitchFamily="50" charset="0"/>
-              </a:rPr>
-              <a:t>amet</a:t>
-            </a:r>
-            <a:r>
-              <a:rPr lang="en-US" sz="2000" dirty="0">
-                <a:latin typeface="UT Sans" pitchFamily="50" charset="0"/>
-              </a:rPr>
-              <a:t> </a:t>
-            </a:r>
-            <a:r>
-              <a:rPr lang="en-US" sz="2000" dirty="0" err="1">
-                <a:latin typeface="UT Sans" pitchFamily="50" charset="0"/>
-              </a:rPr>
-              <a:t>viverra</a:t>
-            </a:r>
-            <a:r>
-              <a:rPr lang="en-US" sz="2000" dirty="0">
-                <a:latin typeface="UT Sans" pitchFamily="50" charset="0"/>
-              </a:rPr>
-              <a:t> a, </a:t>
-            </a:r>
-            <a:r>
-              <a:rPr lang="en-US" sz="2000" dirty="0" err="1">
-                <a:latin typeface="UT Sans" pitchFamily="50" charset="0"/>
-              </a:rPr>
-              <a:t>hendrerit</a:t>
-            </a:r>
-            <a:r>
-              <a:rPr lang="en-US" sz="2000" dirty="0">
-                <a:latin typeface="UT Sans" pitchFamily="50" charset="0"/>
-              </a:rPr>
-              <a:t> vitae </a:t>
-            </a:r>
-            <a:r>
-              <a:rPr lang="en-US" sz="2000" dirty="0" err="1">
-                <a:latin typeface="UT Sans" pitchFamily="50" charset="0"/>
-              </a:rPr>
-              <a:t>nibh</a:t>
-            </a:r>
-            <a:r>
-              <a:rPr lang="en-US" sz="2000" dirty="0">
-                <a:latin typeface="UT Sans" pitchFamily="50" charset="0"/>
-              </a:rPr>
-              <a:t>.</a:t>
-            </a:r>
-          </a:p>
-        </p:txBody>
-      </p:sp>
       <p:pic>
         <p:nvPicPr>
           <p:cNvPr id="2" name="Picture 1"/>
@@ -4697,7 +3987,7 @@
           <p:nvPr/>
         </p:nvPicPr>
         <p:blipFill>
-          <a:blip r:embed="rId3" cstate="print">
+          <a:blip r:embed="rId2" cstate="print">
             <a:extLst>
               <a:ext uri="{28A0092B-C50C-407E-A947-70E740481C1C}">
                 <a14:useLocalDpi xmlns:a14="http://schemas.microsoft.com/office/drawing/2010/main" val="0"/>
@@ -4718,6 +4008,72 @@
           </a:prstGeom>
         </p:spPr>
       </p:pic>
+      <p:pic>
+        <p:nvPicPr>
+          <p:cNvPr id="10" name="Picture 9">
+            <a:extLst>
+              <a:ext uri="{FF2B5EF4-FFF2-40B4-BE49-F238E27FC236}">
+                <a16:creationId xmlns:a16="http://schemas.microsoft.com/office/drawing/2014/main" id="{00DFB170-B35F-3CBD-8CCA-ABD34C1C07B1}"/>
+              </a:ext>
+            </a:extLst>
+          </p:cNvPr>
+          <p:cNvPicPr>
+            <a:picLocks noChangeAspect="1"/>
+          </p:cNvPicPr>
+          <p:nvPr/>
+        </p:nvPicPr>
+        <p:blipFill>
+          <a:blip r:embed="rId3"/>
+          <a:stretch>
+            <a:fillRect/>
+          </a:stretch>
+        </p:blipFill>
+        <p:spPr>
+          <a:xfrm>
+            <a:off x="737574" y="983461"/>
+            <a:ext cx="7668852" cy="5412097"/>
+          </a:xfrm>
+          <a:prstGeom prst="rect">
+            <a:avLst/>
+          </a:prstGeom>
+        </p:spPr>
+      </p:pic>
+      <p:sp>
+        <p:nvSpPr>
+          <p:cNvPr id="11" name="TextBox 10">
+            <a:extLst>
+              <a:ext uri="{FF2B5EF4-FFF2-40B4-BE49-F238E27FC236}">
+                <a16:creationId xmlns:a16="http://schemas.microsoft.com/office/drawing/2014/main" id="{5C3760B6-AF00-BC57-262F-046CDA492B90}"/>
+              </a:ext>
+            </a:extLst>
+          </p:cNvPr>
+          <p:cNvSpPr txBox="1"/>
+          <p:nvPr/>
+        </p:nvSpPr>
+        <p:spPr>
+          <a:xfrm>
+            <a:off x="3095836" y="512676"/>
+            <a:ext cx="5310590" cy="400110"/>
+          </a:xfrm>
+          <a:prstGeom prst="rect">
+            <a:avLst/>
+          </a:prstGeom>
+          <a:noFill/>
+        </p:spPr>
+        <p:txBody>
+          <a:bodyPr wrap="square" rtlCol="0">
+            <a:spAutoFit/>
+          </a:bodyPr>
+          <a:lstStyle/>
+          <a:p>
+            <a:pPr algn="r"/>
+            <a:r>
+              <a:rPr lang="ro-RO" sz="2000" dirty="0"/>
+              <a:t>Schematic</a:t>
+            </a:r>
+          </a:p>
+        </p:txBody>
+      </p:sp>
     </p:spTree>
     <p:extLst>
       <p:ext uri="{BB962C8B-B14F-4D97-AF65-F5344CB8AC3E}">
@@ -4909,6 +4265,71 @@
           </a:prstGeom>
         </p:spPr>
       </p:pic>
+      <p:pic>
+        <p:nvPicPr>
+          <p:cNvPr id="3" name="Picture 2">
+            <a:extLst>
+              <a:ext uri="{FF2B5EF4-FFF2-40B4-BE49-F238E27FC236}">
+                <a16:creationId xmlns:a16="http://schemas.microsoft.com/office/drawing/2014/main" id="{E15E9888-2622-62E5-F0E0-D16A1C12A134}"/>
+              </a:ext>
+            </a:extLst>
+          </p:cNvPr>
+          <p:cNvPicPr>
+            <a:picLocks noChangeAspect="1"/>
+          </p:cNvPicPr>
+          <p:nvPr/>
+        </p:nvPicPr>
+        <p:blipFill>
+          <a:blip r:embed="rId3"/>
+          <a:srcRect l="4408" t="3007" b="2286"/>
+          <a:stretch/>
+        </p:blipFill>
+        <p:spPr>
+          <a:xfrm>
+            <a:off x="499352" y="1052737"/>
+            <a:ext cx="7961080" cy="5256021"/>
+          </a:xfrm>
+          <a:prstGeom prst="rect">
+            <a:avLst/>
+          </a:prstGeom>
+        </p:spPr>
+      </p:pic>
+      <p:sp>
+        <p:nvSpPr>
+          <p:cNvPr id="8" name="TextBox 7">
+            <a:extLst>
+              <a:ext uri="{FF2B5EF4-FFF2-40B4-BE49-F238E27FC236}">
+                <a16:creationId xmlns:a16="http://schemas.microsoft.com/office/drawing/2014/main" id="{03397751-880B-B780-2EB2-D8CB1C51DD1E}"/>
+              </a:ext>
+            </a:extLst>
+          </p:cNvPr>
+          <p:cNvSpPr txBox="1"/>
+          <p:nvPr/>
+        </p:nvSpPr>
+        <p:spPr>
+          <a:xfrm>
+            <a:off x="3095836" y="512676"/>
+            <a:ext cx="5310590" cy="400110"/>
+          </a:xfrm>
+          <a:prstGeom prst="rect">
+            <a:avLst/>
+          </a:prstGeom>
+          <a:noFill/>
+        </p:spPr>
+        <p:txBody>
+          <a:bodyPr wrap="square" rtlCol="0">
+            <a:spAutoFit/>
+          </a:bodyPr>
+          <a:lstStyle/>
+          <a:p>
+            <a:pPr algn="r"/>
+            <a:r>
+              <a:rPr lang="ro-RO" sz="2000" dirty="0"/>
+              <a:t>PCB Design</a:t>
+            </a:r>
+          </a:p>
+        </p:txBody>
+      </p:sp>
     </p:spTree>
     <p:extLst>
       <p:ext uri="{BB962C8B-B14F-4D97-AF65-F5344CB8AC3E}">
@@ -5100,10 +4521,2611 @@
           </a:prstGeom>
         </p:spPr>
       </p:pic>
+      <p:sp>
+        <p:nvSpPr>
+          <p:cNvPr id="2" name="TextBox 1">
+            <a:extLst>
+              <a:ext uri="{FF2B5EF4-FFF2-40B4-BE49-F238E27FC236}">
+                <a16:creationId xmlns:a16="http://schemas.microsoft.com/office/drawing/2014/main" id="{DAE1EA87-E9FB-B2AA-77C6-98CBB063F43A}"/>
+              </a:ext>
+            </a:extLst>
+          </p:cNvPr>
+          <p:cNvSpPr txBox="1"/>
+          <p:nvPr/>
+        </p:nvSpPr>
+        <p:spPr>
+          <a:xfrm>
+            <a:off x="3095836" y="512676"/>
+            <a:ext cx="5310590" cy="400110"/>
+          </a:xfrm>
+          <a:prstGeom prst="rect">
+            <a:avLst/>
+          </a:prstGeom>
+          <a:noFill/>
+        </p:spPr>
+        <p:txBody>
+          <a:bodyPr wrap="square" rtlCol="0">
+            <a:spAutoFit/>
+          </a:bodyPr>
+          <a:lstStyle/>
+          <a:p>
+            <a:pPr algn="r"/>
+            <a:r>
+              <a:rPr lang="ro-RO" sz="2000" dirty="0"/>
+              <a:t>PCB Design </a:t>
+            </a:r>
+            <a:r>
+              <a:rPr lang="ro-RO" sz="2000" dirty="0" err="1"/>
+              <a:t>Bottom</a:t>
+            </a:r>
+            <a:endParaRPr lang="ro-RO" sz="2000" dirty="0"/>
+          </a:p>
+        </p:txBody>
+      </p:sp>
+      <p:pic>
+        <p:nvPicPr>
+          <p:cNvPr id="8" name="Picture 7">
+            <a:extLst>
+              <a:ext uri="{FF2B5EF4-FFF2-40B4-BE49-F238E27FC236}">
+                <a16:creationId xmlns:a16="http://schemas.microsoft.com/office/drawing/2014/main" id="{EDD7A329-AC48-9EB8-13ED-0314A3E7DD8B}"/>
+              </a:ext>
+            </a:extLst>
+          </p:cNvPr>
+          <p:cNvPicPr>
+            <a:picLocks noChangeAspect="1"/>
+          </p:cNvPicPr>
+          <p:nvPr/>
+        </p:nvPicPr>
+        <p:blipFill>
+          <a:blip r:embed="rId3"/>
+          <a:stretch>
+            <a:fillRect/>
+          </a:stretch>
+        </p:blipFill>
+        <p:spPr>
+          <a:xfrm>
+            <a:off x="350384" y="953842"/>
+            <a:ext cx="8028384" cy="5354916"/>
+          </a:xfrm>
+          <a:prstGeom prst="rect">
+            <a:avLst/>
+          </a:prstGeom>
+        </p:spPr>
+      </p:pic>
     </p:spTree>
     <p:extLst>
       <p:ext uri="{BB962C8B-B14F-4D97-AF65-F5344CB8AC3E}">
         <p14:creationId xmlns:p14="http://schemas.microsoft.com/office/powerpoint/2010/main" val="3422904256"/>
+      </p:ext>
+    </p:extLst>
+  </p:cSld>
+  <p:clrMapOvr>
+    <a:masterClrMapping/>
+  </p:clrMapOvr>
+</p:sld>
+</file>
+
+<file path=ppt/slides/slide5.xml><?xml version="1.0" encoding="utf-8"?>
+<p:sld xmlns:a="http://schemas.openxmlformats.org/drawingml/2006/main" xmlns:r="http://schemas.openxmlformats.org/officeDocument/2006/relationships" xmlns:p="http://schemas.openxmlformats.org/presentationml/2006/main">
+  <p:cSld>
+    <p:spTree>
+      <p:nvGrpSpPr>
+        <p:cNvPr id="1" name=""/>
+        <p:cNvGrpSpPr/>
+        <p:nvPr/>
+      </p:nvGrpSpPr>
+      <p:grpSpPr>
+        <a:xfrm>
+          <a:off x="0" y="0"/>
+          <a:ext cx="0" cy="0"/>
+          <a:chOff x="0" y="0"/>
+          <a:chExt cx="0" cy="0"/>
+        </a:xfrm>
+      </p:grpSpPr>
+      <p:grpSp>
+        <p:nvGrpSpPr>
+          <p:cNvPr id="4" name="Group 3"/>
+          <p:cNvGrpSpPr/>
+          <p:nvPr/>
+        </p:nvGrpSpPr>
+        <p:grpSpPr>
+          <a:xfrm>
+            <a:off x="8460432" y="6237312"/>
+            <a:ext cx="216000" cy="216000"/>
+            <a:chOff x="2772000" y="1932221"/>
+            <a:chExt cx="2340000" cy="2340000"/>
+          </a:xfrm>
+        </p:grpSpPr>
+        <p:sp>
+          <p:nvSpPr>
+            <p:cNvPr id="5" name="Rectangle 4"/>
+            <p:cNvSpPr/>
+            <p:nvPr/>
+          </p:nvSpPr>
+          <p:spPr>
+            <a:xfrm>
+              <a:off x="2772000" y="1932221"/>
+              <a:ext cx="2340000" cy="2340000"/>
+            </a:xfrm>
+            <a:prstGeom prst="rect">
+              <a:avLst/>
+            </a:prstGeom>
+            <a:solidFill>
+              <a:schemeClr val="bg1">
+                <a:lumMod val="75000"/>
+              </a:schemeClr>
+            </a:solidFill>
+            <a:ln>
+              <a:noFill/>
+            </a:ln>
+          </p:spPr>
+          <p:style>
+            <a:lnRef idx="2">
+              <a:schemeClr val="accent1">
+                <a:shade val="50000"/>
+              </a:schemeClr>
+            </a:lnRef>
+            <a:fillRef idx="1">
+              <a:schemeClr val="accent1"/>
+            </a:fillRef>
+            <a:effectRef idx="0">
+              <a:schemeClr val="accent1"/>
+            </a:effectRef>
+            <a:fontRef idx="minor">
+              <a:schemeClr val="lt1"/>
+            </a:fontRef>
+          </p:style>
+          <p:txBody>
+            <a:bodyPr rtlCol="0" anchor="ctr"/>
+            <a:lstStyle/>
+            <a:p>
+              <a:pPr algn="ctr"/>
+              <a:endParaRPr lang="en-US">
+                <a:ln>
+                  <a:solidFill>
+                    <a:schemeClr val="bg2">
+                      <a:lumMod val="75000"/>
+                    </a:schemeClr>
+                  </a:solidFill>
+                </a:ln>
+                <a:solidFill>
+                  <a:schemeClr val="tx1"/>
+                </a:solidFill>
+              </a:endParaRPr>
+            </a:p>
+          </p:txBody>
+        </p:sp>
+        <p:sp>
+          <p:nvSpPr>
+            <p:cNvPr id="6" name="Rectangle 5"/>
+            <p:cNvSpPr/>
+            <p:nvPr/>
+          </p:nvSpPr>
+          <p:spPr>
+            <a:xfrm>
+              <a:off x="3546000" y="2706221"/>
+              <a:ext cx="792000" cy="792000"/>
+            </a:xfrm>
+            <a:prstGeom prst="rect">
+              <a:avLst/>
+            </a:prstGeom>
+            <a:solidFill>
+              <a:schemeClr val="bg1"/>
+            </a:solidFill>
+            <a:ln>
+              <a:noFill/>
+            </a:ln>
+          </p:spPr>
+          <p:style>
+            <a:lnRef idx="2">
+              <a:schemeClr val="accent1">
+                <a:shade val="50000"/>
+              </a:schemeClr>
+            </a:lnRef>
+            <a:fillRef idx="1">
+              <a:schemeClr val="accent1"/>
+            </a:fillRef>
+            <a:effectRef idx="0">
+              <a:schemeClr val="accent1"/>
+            </a:effectRef>
+            <a:fontRef idx="minor">
+              <a:schemeClr val="lt1"/>
+            </a:fontRef>
+          </p:style>
+          <p:txBody>
+            <a:bodyPr rtlCol="0" anchor="ctr"/>
+            <a:lstStyle/>
+            <a:p>
+              <a:pPr algn="ctr"/>
+              <a:endParaRPr lang="en-US">
+                <a:ln>
+                  <a:solidFill>
+                    <a:schemeClr val="bg2">
+                      <a:lumMod val="75000"/>
+                    </a:schemeClr>
+                  </a:solidFill>
+                </a:ln>
+                <a:solidFill>
+                  <a:schemeClr val="tx1"/>
+                </a:solidFill>
+              </a:endParaRPr>
+            </a:p>
+          </p:txBody>
+        </p:sp>
+      </p:grpSp>
+      <p:pic>
+        <p:nvPicPr>
+          <p:cNvPr id="7" name="Picture 6"/>
+          <p:cNvPicPr>
+            <a:picLocks noChangeAspect="1"/>
+          </p:cNvPicPr>
+          <p:nvPr/>
+        </p:nvPicPr>
+        <p:blipFill>
+          <a:blip r:embed="rId2" cstate="print">
+            <a:extLst>
+              <a:ext uri="{28A0092B-C50C-407E-A947-70E740481C1C}">
+                <a14:useLocalDpi xmlns:a14="http://schemas.microsoft.com/office/drawing/2010/main" val="0"/>
+              </a:ext>
+            </a:extLst>
+          </a:blip>
+          <a:stretch>
+            <a:fillRect/>
+          </a:stretch>
+        </p:blipFill>
+        <p:spPr>
+          <a:xfrm>
+            <a:off x="359532" y="341671"/>
+            <a:ext cx="1944216" cy="531045"/>
+          </a:xfrm>
+          <a:prstGeom prst="rect">
+            <a:avLst/>
+          </a:prstGeom>
+        </p:spPr>
+      </p:pic>
+      <p:sp>
+        <p:nvSpPr>
+          <p:cNvPr id="2" name="TextBox 1">
+            <a:extLst>
+              <a:ext uri="{FF2B5EF4-FFF2-40B4-BE49-F238E27FC236}">
+                <a16:creationId xmlns:a16="http://schemas.microsoft.com/office/drawing/2014/main" id="{DAE1EA87-E9FB-B2AA-77C6-98CBB063F43A}"/>
+              </a:ext>
+            </a:extLst>
+          </p:cNvPr>
+          <p:cNvSpPr txBox="1"/>
+          <p:nvPr/>
+        </p:nvSpPr>
+        <p:spPr>
+          <a:xfrm>
+            <a:off x="3095836" y="512676"/>
+            <a:ext cx="5310590" cy="400110"/>
+          </a:xfrm>
+          <a:prstGeom prst="rect">
+            <a:avLst/>
+          </a:prstGeom>
+          <a:noFill/>
+        </p:spPr>
+        <p:txBody>
+          <a:bodyPr wrap="square" rtlCol="0">
+            <a:spAutoFit/>
+          </a:bodyPr>
+          <a:lstStyle/>
+          <a:p>
+            <a:pPr algn="r"/>
+            <a:r>
+              <a:rPr lang="ro-RO" sz="2000" dirty="0"/>
+              <a:t>PCB Design 3D</a:t>
+            </a:r>
+          </a:p>
+        </p:txBody>
+      </p:sp>
+      <p:pic>
+        <p:nvPicPr>
+          <p:cNvPr id="9" name="Picture 8">
+            <a:extLst>
+              <a:ext uri="{FF2B5EF4-FFF2-40B4-BE49-F238E27FC236}">
+                <a16:creationId xmlns:a16="http://schemas.microsoft.com/office/drawing/2014/main" id="{95EA5C94-0F06-B5B8-08AC-664C11C51062}"/>
+              </a:ext>
+            </a:extLst>
+          </p:cNvPr>
+          <p:cNvPicPr>
+            <a:picLocks noChangeAspect="1"/>
+          </p:cNvPicPr>
+          <p:nvPr/>
+        </p:nvPicPr>
+        <p:blipFill>
+          <a:blip r:embed="rId3"/>
+          <a:srcRect l="16532" t="20338" r="21256" b="13493"/>
+          <a:stretch/>
+        </p:blipFill>
+        <p:spPr>
+          <a:xfrm>
+            <a:off x="431540" y="1178716"/>
+            <a:ext cx="8173446" cy="4500568"/>
+          </a:xfrm>
+          <a:prstGeom prst="rect">
+            <a:avLst/>
+          </a:prstGeom>
+        </p:spPr>
+      </p:pic>
+    </p:spTree>
+    <p:extLst>
+      <p:ext uri="{BB962C8B-B14F-4D97-AF65-F5344CB8AC3E}">
+        <p14:creationId xmlns:p14="http://schemas.microsoft.com/office/powerpoint/2010/main" val="3531132025"/>
+      </p:ext>
+    </p:extLst>
+  </p:cSld>
+  <p:clrMapOvr>
+    <a:masterClrMapping/>
+  </p:clrMapOvr>
+</p:sld>
+</file>
+
+<file path=ppt/slides/slide6.xml><?xml version="1.0" encoding="utf-8"?>
+<p:sld xmlns:a="http://schemas.openxmlformats.org/drawingml/2006/main" xmlns:r="http://schemas.openxmlformats.org/officeDocument/2006/relationships" xmlns:p="http://schemas.openxmlformats.org/presentationml/2006/main">
+  <p:cSld>
+    <p:spTree>
+      <p:nvGrpSpPr>
+        <p:cNvPr id="1" name=""/>
+        <p:cNvGrpSpPr/>
+        <p:nvPr/>
+      </p:nvGrpSpPr>
+      <p:grpSpPr>
+        <a:xfrm>
+          <a:off x="0" y="0"/>
+          <a:ext cx="0" cy="0"/>
+          <a:chOff x="0" y="0"/>
+          <a:chExt cx="0" cy="0"/>
+        </a:xfrm>
+      </p:grpSpPr>
+      <p:grpSp>
+        <p:nvGrpSpPr>
+          <p:cNvPr id="4" name="Group 3"/>
+          <p:cNvGrpSpPr/>
+          <p:nvPr/>
+        </p:nvGrpSpPr>
+        <p:grpSpPr>
+          <a:xfrm>
+            <a:off x="8460432" y="6237312"/>
+            <a:ext cx="216000" cy="216000"/>
+            <a:chOff x="2772000" y="1932221"/>
+            <a:chExt cx="2340000" cy="2340000"/>
+          </a:xfrm>
+        </p:grpSpPr>
+        <p:sp>
+          <p:nvSpPr>
+            <p:cNvPr id="5" name="Rectangle 4"/>
+            <p:cNvSpPr/>
+            <p:nvPr/>
+          </p:nvSpPr>
+          <p:spPr>
+            <a:xfrm>
+              <a:off x="2772000" y="1932221"/>
+              <a:ext cx="2340000" cy="2340000"/>
+            </a:xfrm>
+            <a:prstGeom prst="rect">
+              <a:avLst/>
+            </a:prstGeom>
+            <a:solidFill>
+              <a:schemeClr val="bg1">
+                <a:lumMod val="75000"/>
+              </a:schemeClr>
+            </a:solidFill>
+            <a:ln>
+              <a:noFill/>
+            </a:ln>
+          </p:spPr>
+          <p:style>
+            <a:lnRef idx="2">
+              <a:schemeClr val="accent1">
+                <a:shade val="50000"/>
+              </a:schemeClr>
+            </a:lnRef>
+            <a:fillRef idx="1">
+              <a:schemeClr val="accent1"/>
+            </a:fillRef>
+            <a:effectRef idx="0">
+              <a:schemeClr val="accent1"/>
+            </a:effectRef>
+            <a:fontRef idx="minor">
+              <a:schemeClr val="lt1"/>
+            </a:fontRef>
+          </p:style>
+          <p:txBody>
+            <a:bodyPr rtlCol="0" anchor="ctr"/>
+            <a:lstStyle/>
+            <a:p>
+              <a:pPr marL="0" marR="0" lvl="0" indent="0" algn="ctr" defTabSz="914400" rtl="0" eaLnBrk="1" fontAlgn="auto" latinLnBrk="0" hangingPunct="1">
+                <a:lnSpc>
+                  <a:spcPct val="100000"/>
+                </a:lnSpc>
+                <a:spcBef>
+                  <a:spcPts val="0"/>
+                </a:spcBef>
+                <a:spcAft>
+                  <a:spcPts val="0"/>
+                </a:spcAft>
+                <a:buClrTx/>
+                <a:buSzTx/>
+                <a:buFontTx/>
+                <a:buNone/>
+                <a:tabLst/>
+                <a:defRPr/>
+              </a:pPr>
+              <a:endParaRPr kumimoji="0" lang="en-US" sz="1800" b="0" i="0" u="none" strike="noStrike" kern="1200" cap="none" spc="0" normalizeH="0" baseline="0" noProof="0">
+                <a:ln>
+                  <a:solidFill>
+                    <a:srgbClr val="E7E6E6">
+                      <a:lumMod val="75000"/>
+                    </a:srgbClr>
+                  </a:solidFill>
+                </a:ln>
+                <a:solidFill>
+                  <a:prstClr val="black"/>
+                </a:solidFill>
+                <a:effectLst/>
+                <a:uLnTx/>
+                <a:uFillTx/>
+                <a:latin typeface="Calibri" panose="020F0502020204030204"/>
+                <a:ea typeface="+mn-ea"/>
+                <a:cs typeface="+mn-cs"/>
+              </a:endParaRPr>
+            </a:p>
+          </p:txBody>
+        </p:sp>
+        <p:sp>
+          <p:nvSpPr>
+            <p:cNvPr id="6" name="Rectangle 5"/>
+            <p:cNvSpPr/>
+            <p:nvPr/>
+          </p:nvSpPr>
+          <p:spPr>
+            <a:xfrm>
+              <a:off x="3546000" y="2706221"/>
+              <a:ext cx="792000" cy="792000"/>
+            </a:xfrm>
+            <a:prstGeom prst="rect">
+              <a:avLst/>
+            </a:prstGeom>
+            <a:solidFill>
+              <a:schemeClr val="bg1"/>
+            </a:solidFill>
+            <a:ln>
+              <a:noFill/>
+            </a:ln>
+          </p:spPr>
+          <p:style>
+            <a:lnRef idx="2">
+              <a:schemeClr val="accent1">
+                <a:shade val="50000"/>
+              </a:schemeClr>
+            </a:lnRef>
+            <a:fillRef idx="1">
+              <a:schemeClr val="accent1"/>
+            </a:fillRef>
+            <a:effectRef idx="0">
+              <a:schemeClr val="accent1"/>
+            </a:effectRef>
+            <a:fontRef idx="minor">
+              <a:schemeClr val="lt1"/>
+            </a:fontRef>
+          </p:style>
+          <p:txBody>
+            <a:bodyPr rtlCol="0" anchor="ctr"/>
+            <a:lstStyle/>
+            <a:p>
+              <a:pPr marL="0" marR="0" lvl="0" indent="0" algn="ctr" defTabSz="914400" rtl="0" eaLnBrk="1" fontAlgn="auto" latinLnBrk="0" hangingPunct="1">
+                <a:lnSpc>
+                  <a:spcPct val="100000"/>
+                </a:lnSpc>
+                <a:spcBef>
+                  <a:spcPts val="0"/>
+                </a:spcBef>
+                <a:spcAft>
+                  <a:spcPts val="0"/>
+                </a:spcAft>
+                <a:buClrTx/>
+                <a:buSzTx/>
+                <a:buFontTx/>
+                <a:buNone/>
+                <a:tabLst/>
+                <a:defRPr/>
+              </a:pPr>
+              <a:endParaRPr kumimoji="0" lang="en-US" sz="1800" b="0" i="0" u="none" strike="noStrike" kern="1200" cap="none" spc="0" normalizeH="0" baseline="0" noProof="0">
+                <a:ln>
+                  <a:solidFill>
+                    <a:srgbClr val="E7E6E6">
+                      <a:lumMod val="75000"/>
+                    </a:srgbClr>
+                  </a:solidFill>
+                </a:ln>
+                <a:solidFill>
+                  <a:prstClr val="black"/>
+                </a:solidFill>
+                <a:effectLst/>
+                <a:uLnTx/>
+                <a:uFillTx/>
+                <a:latin typeface="Calibri" panose="020F0502020204030204"/>
+                <a:ea typeface="+mn-ea"/>
+                <a:cs typeface="+mn-cs"/>
+              </a:endParaRPr>
+            </a:p>
+          </p:txBody>
+        </p:sp>
+      </p:grpSp>
+      <p:sp>
+        <p:nvSpPr>
+          <p:cNvPr id="7" name="TextBox 6"/>
+          <p:cNvSpPr txBox="1"/>
+          <p:nvPr/>
+        </p:nvSpPr>
+        <p:spPr>
+          <a:xfrm>
+            <a:off x="611560" y="1044019"/>
+            <a:ext cx="7848872" cy="4670509"/>
+          </a:xfrm>
+          <a:prstGeom prst="rect">
+            <a:avLst/>
+          </a:prstGeom>
+          <a:noFill/>
+        </p:spPr>
+        <p:txBody>
+          <a:bodyPr wrap="square" rtlCol="0">
+            <a:spAutoFit/>
+          </a:bodyPr>
+          <a:lstStyle/>
+          <a:p>
+            <a:pPr marR="0" lvl="0" algn="just" defTabSz="914400" rtl="0" eaLnBrk="1" fontAlgn="auto" latinLnBrk="0" hangingPunct="1">
+              <a:lnSpc>
+                <a:spcPct val="150000"/>
+              </a:lnSpc>
+              <a:spcBef>
+                <a:spcPts val="0"/>
+              </a:spcBef>
+              <a:spcAft>
+                <a:spcPts val="0"/>
+              </a:spcAft>
+              <a:buClrTx/>
+              <a:buSzTx/>
+              <a:tabLst/>
+              <a:defRPr/>
+            </a:pPr>
+            <a:r>
+              <a:rPr kumimoji="0" lang="en-US" sz="2000" b="0" i="0" u="none" strike="noStrike" kern="1200" cap="none" spc="0" normalizeH="0" baseline="0" noProof="0" dirty="0">
+                <a:ln>
+                  <a:noFill/>
+                </a:ln>
+                <a:solidFill>
+                  <a:prstClr val="black"/>
+                </a:solidFill>
+                <a:effectLst/>
+                <a:uLnTx/>
+                <a:uFillTx/>
+                <a:latin typeface="UT Sans" pitchFamily="50" charset="0"/>
+                <a:ea typeface="+mn-ea"/>
+                <a:cs typeface="+mn-cs"/>
+              </a:rPr>
+              <a:t>• Backwards compatibility cu Arduino IDE (</a:t>
+            </a:r>
+            <a:r>
+              <a:rPr kumimoji="0" lang="en-US" sz="2000" b="0" i="0" u="none" strike="noStrike" kern="1200" cap="none" spc="0" normalizeH="0" baseline="0" noProof="0" dirty="0" err="1">
+                <a:ln>
+                  <a:noFill/>
+                </a:ln>
+                <a:solidFill>
+                  <a:prstClr val="black"/>
+                </a:solidFill>
+                <a:effectLst/>
+                <a:uLnTx/>
+                <a:uFillTx/>
+                <a:latin typeface="UT Sans" pitchFamily="50" charset="0"/>
+                <a:ea typeface="+mn-ea"/>
+                <a:cs typeface="+mn-cs"/>
+              </a:rPr>
+              <a:t>maparea</a:t>
+            </a:r>
+            <a:r>
+              <a:rPr kumimoji="0" lang="en-US" sz="2000" b="0" i="0" u="none" strike="noStrike" kern="1200" cap="none" spc="0" normalizeH="0" baseline="0" noProof="0" dirty="0">
+                <a:ln>
+                  <a:noFill/>
+                </a:ln>
+                <a:solidFill>
+                  <a:prstClr val="black"/>
+                </a:solidFill>
+                <a:effectLst/>
+                <a:uLnTx/>
+                <a:uFillTx/>
+                <a:latin typeface="UT Sans" pitchFamily="50" charset="0"/>
+                <a:ea typeface="+mn-ea"/>
+                <a:cs typeface="+mn-cs"/>
+              </a:rPr>
+              <a:t> </a:t>
+            </a:r>
+            <a:r>
+              <a:rPr kumimoji="0" lang="en-US" sz="2000" b="0" i="0" u="none" strike="noStrike" kern="1200" cap="none" spc="0" normalizeH="0" baseline="0" noProof="0" dirty="0" err="1">
+                <a:ln>
+                  <a:noFill/>
+                </a:ln>
+                <a:solidFill>
+                  <a:prstClr val="black"/>
+                </a:solidFill>
+                <a:effectLst/>
+                <a:uLnTx/>
+                <a:uFillTx/>
+                <a:latin typeface="UT Sans" pitchFamily="50" charset="0"/>
+                <a:ea typeface="+mn-ea"/>
+                <a:cs typeface="+mn-cs"/>
+              </a:rPr>
+              <a:t>pinilor</a:t>
+            </a:r>
+            <a:r>
+              <a:rPr kumimoji="0" lang="en-US" sz="2000" b="0" i="0" u="none" strike="noStrike" kern="1200" cap="none" spc="0" normalizeH="0" baseline="0" noProof="0" dirty="0">
+                <a:ln>
+                  <a:noFill/>
+                </a:ln>
+                <a:solidFill>
+                  <a:prstClr val="black"/>
+                </a:solidFill>
+                <a:effectLst/>
+                <a:uLnTx/>
+                <a:uFillTx/>
+                <a:latin typeface="UT Sans" pitchFamily="50" charset="0"/>
+                <a:ea typeface="+mn-ea"/>
+                <a:cs typeface="+mn-cs"/>
+              </a:rPr>
+              <a:t> </a:t>
+            </a:r>
+            <a:r>
+              <a:rPr kumimoji="0" lang="en-US" sz="2000" b="0" i="0" u="none" strike="noStrike" kern="1200" cap="none" spc="0" normalizeH="0" baseline="0" noProof="0" dirty="0" err="1">
+                <a:ln>
+                  <a:noFill/>
+                </a:ln>
+                <a:solidFill>
+                  <a:prstClr val="black"/>
+                </a:solidFill>
+                <a:effectLst/>
+                <a:uLnTx/>
+                <a:uFillTx/>
+                <a:latin typeface="UT Sans" pitchFamily="50" charset="0"/>
+                <a:ea typeface="+mn-ea"/>
+                <a:cs typeface="+mn-cs"/>
+              </a:rPr>
+              <a:t>este</a:t>
+            </a:r>
+            <a:r>
+              <a:rPr kumimoji="0" lang="en-US" sz="2000" b="0" i="0" u="none" strike="noStrike" kern="1200" cap="none" spc="0" normalizeH="0" baseline="0" noProof="0" dirty="0">
+                <a:ln>
+                  <a:noFill/>
+                </a:ln>
+                <a:solidFill>
+                  <a:prstClr val="black"/>
+                </a:solidFill>
+                <a:effectLst/>
+                <a:uLnTx/>
+                <a:uFillTx/>
+                <a:latin typeface="UT Sans" pitchFamily="50" charset="0"/>
+                <a:ea typeface="+mn-ea"/>
+                <a:cs typeface="+mn-cs"/>
+              </a:rPr>
+              <a:t> </a:t>
+            </a:r>
+            <a:r>
+              <a:rPr kumimoji="0" lang="en-US" sz="2000" b="0" i="0" u="none" strike="noStrike" kern="1200" cap="none" spc="0" normalizeH="0" baseline="0" noProof="0" dirty="0" err="1">
+                <a:ln>
+                  <a:noFill/>
+                </a:ln>
+                <a:solidFill>
+                  <a:prstClr val="black"/>
+                </a:solidFill>
+                <a:effectLst/>
+                <a:uLnTx/>
+                <a:uFillTx/>
+                <a:latin typeface="UT Sans" pitchFamily="50" charset="0"/>
+                <a:ea typeface="+mn-ea"/>
+                <a:cs typeface="+mn-cs"/>
+              </a:rPr>
+              <a:t>realizată</a:t>
+            </a:r>
+            <a:r>
+              <a:rPr kumimoji="0" lang="en-US" sz="2000" b="0" i="0" u="none" strike="noStrike" kern="1200" cap="none" spc="0" normalizeH="0" baseline="0" noProof="0" dirty="0">
+                <a:ln>
+                  <a:noFill/>
+                </a:ln>
+                <a:solidFill>
+                  <a:prstClr val="black"/>
+                </a:solidFill>
+                <a:effectLst/>
+                <a:uLnTx/>
+                <a:uFillTx/>
+                <a:latin typeface="UT Sans" pitchFamily="50" charset="0"/>
+                <a:ea typeface="+mn-ea"/>
+                <a:cs typeface="+mn-cs"/>
+              </a:rPr>
+              <a:t> </a:t>
+            </a:r>
+            <a:r>
+              <a:rPr kumimoji="0" lang="en-US" sz="2000" b="0" i="0" u="none" strike="noStrike" kern="1200" cap="none" spc="0" normalizeH="0" baseline="0" noProof="0" dirty="0" err="1">
+                <a:ln>
+                  <a:noFill/>
+                </a:ln>
+                <a:solidFill>
+                  <a:prstClr val="black"/>
+                </a:solidFill>
+                <a:effectLst/>
+                <a:uLnTx/>
+                <a:uFillTx/>
+                <a:latin typeface="UT Sans" pitchFamily="50" charset="0"/>
+                <a:ea typeface="+mn-ea"/>
+                <a:cs typeface="+mn-cs"/>
+              </a:rPr>
+              <a:t>în</a:t>
+            </a:r>
+            <a:r>
+              <a:rPr kumimoji="0" lang="en-US" sz="2000" b="0" i="0" u="none" strike="noStrike" kern="1200" cap="none" spc="0" normalizeH="0" baseline="0" noProof="0" dirty="0">
+                <a:ln>
+                  <a:noFill/>
+                </a:ln>
+                <a:solidFill>
+                  <a:prstClr val="black"/>
+                </a:solidFill>
+                <a:effectLst/>
+                <a:uLnTx/>
+                <a:uFillTx/>
+                <a:latin typeface="UT Sans" pitchFamily="50" charset="0"/>
+                <a:ea typeface="+mn-ea"/>
+                <a:cs typeface="+mn-cs"/>
+              </a:rPr>
+              <a:t> </a:t>
+            </a:r>
+            <a:r>
+              <a:rPr kumimoji="0" lang="en-US" sz="2000" b="0" i="0" u="none" strike="noStrike" kern="1200" cap="none" spc="0" normalizeH="0" baseline="0" noProof="0" dirty="0" err="1">
+                <a:ln>
+                  <a:noFill/>
+                </a:ln>
+                <a:solidFill>
+                  <a:prstClr val="black"/>
+                </a:solidFill>
+                <a:effectLst/>
+                <a:uLnTx/>
+                <a:uFillTx/>
+                <a:latin typeface="UT Sans" pitchFamily="50" charset="0"/>
+                <a:ea typeface="+mn-ea"/>
+                <a:cs typeface="+mn-cs"/>
+              </a:rPr>
+              <a:t>stil</a:t>
+            </a:r>
+            <a:r>
+              <a:rPr kumimoji="0" lang="en-US" sz="2000" b="0" i="0" u="none" strike="noStrike" kern="1200" cap="none" spc="0" normalizeH="0" baseline="0" noProof="0" dirty="0">
+                <a:ln>
+                  <a:noFill/>
+                </a:ln>
+                <a:solidFill>
+                  <a:prstClr val="black"/>
+                </a:solidFill>
+                <a:effectLst/>
+                <a:uLnTx/>
+                <a:uFillTx/>
+                <a:latin typeface="UT Sans" pitchFamily="50" charset="0"/>
+                <a:ea typeface="+mn-ea"/>
+                <a:cs typeface="+mn-cs"/>
+              </a:rPr>
+              <a:t> Arduino Mega)</a:t>
+            </a:r>
+          </a:p>
+          <a:p>
+            <a:pPr marR="0" lvl="0" algn="just" defTabSz="914400" rtl="0" eaLnBrk="1" fontAlgn="auto" latinLnBrk="0" hangingPunct="1">
+              <a:lnSpc>
+                <a:spcPct val="150000"/>
+              </a:lnSpc>
+              <a:spcBef>
+                <a:spcPts val="0"/>
+              </a:spcBef>
+              <a:spcAft>
+                <a:spcPts val="0"/>
+              </a:spcAft>
+              <a:buClrTx/>
+              <a:buSzTx/>
+              <a:tabLst/>
+              <a:defRPr/>
+            </a:pPr>
+            <a:r>
+              <a:rPr kumimoji="0" lang="en-US" sz="2000" b="0" i="0" u="none" strike="noStrike" kern="1200" cap="none" spc="0" normalizeH="0" baseline="0" noProof="0" dirty="0">
+                <a:ln>
+                  <a:noFill/>
+                </a:ln>
+                <a:solidFill>
+                  <a:prstClr val="black"/>
+                </a:solidFill>
+                <a:effectLst/>
+                <a:uLnTx/>
+                <a:uFillTx/>
+                <a:latin typeface="UT Sans" pitchFamily="50" charset="0"/>
+                <a:ea typeface="+mn-ea"/>
+                <a:cs typeface="+mn-cs"/>
+              </a:rPr>
+              <a:t>• </a:t>
+            </a:r>
+            <a:r>
+              <a:rPr kumimoji="0" lang="en-US" sz="2000" b="0" i="0" u="none" strike="noStrike" kern="1200" cap="none" spc="0" normalizeH="0" baseline="0" noProof="0" dirty="0" err="1">
+                <a:ln>
+                  <a:noFill/>
+                </a:ln>
+                <a:solidFill>
+                  <a:prstClr val="black"/>
+                </a:solidFill>
+                <a:effectLst/>
+                <a:uLnTx/>
+                <a:uFillTx/>
+                <a:latin typeface="UT Sans" pitchFamily="50" charset="0"/>
+                <a:ea typeface="+mn-ea"/>
+                <a:cs typeface="+mn-cs"/>
+              </a:rPr>
+              <a:t>Frecvență</a:t>
+            </a:r>
+            <a:r>
+              <a:rPr kumimoji="0" lang="en-US" sz="2000" b="0" i="0" u="none" strike="noStrike" kern="1200" cap="none" spc="0" normalizeH="0" baseline="0" noProof="0" dirty="0">
+                <a:ln>
+                  <a:noFill/>
+                </a:ln>
+                <a:solidFill>
+                  <a:prstClr val="black"/>
+                </a:solidFill>
+                <a:effectLst/>
+                <a:uLnTx/>
+                <a:uFillTx/>
+                <a:latin typeface="UT Sans" pitchFamily="50" charset="0"/>
+                <a:ea typeface="+mn-ea"/>
+                <a:cs typeface="+mn-cs"/>
+              </a:rPr>
+              <a:t> </a:t>
+            </a:r>
+            <a:r>
+              <a:rPr kumimoji="0" lang="en-US" sz="2000" b="0" i="0" u="none" strike="noStrike" kern="1200" cap="none" spc="0" normalizeH="0" baseline="0" noProof="0" dirty="0" err="1">
+                <a:ln>
+                  <a:noFill/>
+                </a:ln>
+                <a:solidFill>
+                  <a:prstClr val="black"/>
+                </a:solidFill>
+                <a:effectLst/>
+                <a:uLnTx/>
+                <a:uFillTx/>
+                <a:latin typeface="UT Sans" pitchFamily="50" charset="0"/>
+                <a:ea typeface="+mn-ea"/>
+                <a:cs typeface="+mn-cs"/>
+              </a:rPr>
+              <a:t>maximă</a:t>
+            </a:r>
+            <a:r>
+              <a:rPr kumimoji="0" lang="en-US" sz="2000" b="0" i="0" u="none" strike="noStrike" kern="1200" cap="none" spc="0" normalizeH="0" baseline="0" noProof="0" dirty="0">
+                <a:ln>
+                  <a:noFill/>
+                </a:ln>
+                <a:solidFill>
+                  <a:prstClr val="black"/>
+                </a:solidFill>
+                <a:effectLst/>
+                <a:uLnTx/>
+                <a:uFillTx/>
+                <a:latin typeface="UT Sans" pitchFamily="50" charset="0"/>
+                <a:ea typeface="+mn-ea"/>
+                <a:cs typeface="+mn-cs"/>
+              </a:rPr>
+              <a:t> a </a:t>
+            </a:r>
+            <a:r>
+              <a:rPr kumimoji="0" lang="en-US" sz="2000" b="0" i="0" u="none" strike="noStrike" kern="1200" cap="none" spc="0" normalizeH="0" baseline="0" noProof="0" dirty="0" err="1">
+                <a:ln>
+                  <a:noFill/>
+                </a:ln>
+                <a:solidFill>
+                  <a:prstClr val="black"/>
+                </a:solidFill>
+                <a:effectLst/>
+                <a:uLnTx/>
+                <a:uFillTx/>
+                <a:latin typeface="UT Sans" pitchFamily="50" charset="0"/>
+                <a:ea typeface="+mn-ea"/>
+                <a:cs typeface="+mn-cs"/>
+              </a:rPr>
+              <a:t>semnalului</a:t>
+            </a:r>
+            <a:r>
+              <a:rPr kumimoji="0" lang="en-US" sz="2000" b="0" i="0" u="none" strike="noStrike" kern="1200" cap="none" spc="0" normalizeH="0" baseline="0" noProof="0" dirty="0">
+                <a:ln>
+                  <a:noFill/>
+                </a:ln>
+                <a:solidFill>
+                  <a:prstClr val="black"/>
+                </a:solidFill>
+                <a:effectLst/>
+                <a:uLnTx/>
+                <a:uFillTx/>
+                <a:latin typeface="UT Sans" pitchFamily="50" charset="0"/>
+                <a:ea typeface="+mn-ea"/>
+                <a:cs typeface="+mn-cs"/>
+              </a:rPr>
+              <a:t> de </a:t>
+            </a:r>
+            <a:r>
+              <a:rPr kumimoji="0" lang="en-US" sz="2000" b="0" i="0" u="none" strike="noStrike" kern="1200" cap="none" spc="0" normalizeH="0" baseline="0" noProof="0" dirty="0" err="1">
+                <a:ln>
+                  <a:noFill/>
+                </a:ln>
+                <a:solidFill>
+                  <a:prstClr val="black"/>
+                </a:solidFill>
+                <a:effectLst/>
+                <a:uLnTx/>
+                <a:uFillTx/>
+                <a:latin typeface="UT Sans" pitchFamily="50" charset="0"/>
+                <a:ea typeface="+mn-ea"/>
+                <a:cs typeface="+mn-cs"/>
+              </a:rPr>
+              <a:t>măsurat</a:t>
+            </a:r>
+            <a:r>
+              <a:rPr kumimoji="0" lang="en-US" sz="2000" b="0" i="0" u="none" strike="noStrike" kern="1200" cap="none" spc="0" normalizeH="0" baseline="0" noProof="0" dirty="0">
+                <a:ln>
+                  <a:noFill/>
+                </a:ln>
+                <a:solidFill>
+                  <a:prstClr val="black"/>
+                </a:solidFill>
+                <a:effectLst/>
+                <a:uLnTx/>
+                <a:uFillTx/>
+                <a:latin typeface="UT Sans" pitchFamily="50" charset="0"/>
+                <a:ea typeface="+mn-ea"/>
+                <a:cs typeface="+mn-cs"/>
+              </a:rPr>
+              <a:t> circa 300kHz (</a:t>
+            </a:r>
+            <a:r>
+              <a:rPr kumimoji="0" lang="en-US" sz="2000" b="0" i="0" u="none" strike="noStrike" kern="1200" cap="none" spc="0" normalizeH="0" baseline="0" noProof="0" dirty="0" err="1">
+                <a:ln>
+                  <a:noFill/>
+                </a:ln>
+                <a:solidFill>
+                  <a:prstClr val="black"/>
+                </a:solidFill>
+                <a:effectLst/>
+                <a:uLnTx/>
+                <a:uFillTx/>
+                <a:latin typeface="UT Sans" pitchFamily="50" charset="0"/>
+                <a:ea typeface="+mn-ea"/>
+                <a:cs typeface="+mn-cs"/>
+              </a:rPr>
+              <a:t>în</a:t>
+            </a:r>
+            <a:r>
+              <a:rPr kumimoji="0" lang="en-US" sz="2000" b="0" i="0" u="none" strike="noStrike" kern="1200" cap="none" spc="0" normalizeH="0" baseline="0" noProof="0" dirty="0">
+                <a:ln>
+                  <a:noFill/>
+                </a:ln>
+                <a:solidFill>
+                  <a:prstClr val="black"/>
+                </a:solidFill>
+                <a:effectLst/>
+                <a:uLnTx/>
+                <a:uFillTx/>
+                <a:latin typeface="UT Sans" pitchFamily="50" charset="0"/>
+                <a:ea typeface="+mn-ea"/>
+                <a:cs typeface="+mn-cs"/>
+              </a:rPr>
+              <a:t> </a:t>
+            </a:r>
+            <a:r>
+              <a:rPr kumimoji="0" lang="en-US" sz="2000" b="0" i="0" u="none" strike="noStrike" kern="1200" cap="none" spc="0" normalizeH="0" baseline="0" noProof="0" dirty="0" err="1">
+                <a:ln>
+                  <a:noFill/>
+                </a:ln>
+                <a:solidFill>
+                  <a:prstClr val="black"/>
+                </a:solidFill>
+                <a:effectLst/>
+                <a:uLnTx/>
+                <a:uFillTx/>
+                <a:latin typeface="UT Sans" pitchFamily="50" charset="0"/>
+                <a:ea typeface="+mn-ea"/>
+                <a:cs typeface="+mn-cs"/>
+              </a:rPr>
+              <a:t>funcție</a:t>
+            </a:r>
+            <a:r>
+              <a:rPr kumimoji="0" lang="en-US" sz="2000" b="0" i="0" u="none" strike="noStrike" kern="1200" cap="none" spc="0" normalizeH="0" baseline="0" noProof="0" dirty="0">
+                <a:ln>
+                  <a:noFill/>
+                </a:ln>
+                <a:solidFill>
+                  <a:prstClr val="black"/>
+                </a:solidFill>
+                <a:effectLst/>
+                <a:uLnTx/>
+                <a:uFillTx/>
+                <a:latin typeface="UT Sans" pitchFamily="50" charset="0"/>
+                <a:ea typeface="+mn-ea"/>
+                <a:cs typeface="+mn-cs"/>
+              </a:rPr>
+              <a:t> de </a:t>
+            </a:r>
+            <a:r>
+              <a:rPr kumimoji="0" lang="en-US" sz="2000" b="0" i="0" u="none" strike="noStrike" kern="1200" cap="none" spc="0" normalizeH="0" baseline="0" noProof="0" dirty="0" err="1">
+                <a:ln>
+                  <a:noFill/>
+                </a:ln>
+                <a:solidFill>
+                  <a:prstClr val="black"/>
+                </a:solidFill>
+                <a:effectLst/>
+                <a:uLnTx/>
+                <a:uFillTx/>
+                <a:latin typeface="UT Sans" pitchFamily="50" charset="0"/>
+                <a:ea typeface="+mn-ea"/>
+                <a:cs typeface="+mn-cs"/>
+              </a:rPr>
+              <a:t>configurarea</a:t>
+            </a:r>
+            <a:r>
+              <a:rPr kumimoji="0" lang="en-US" sz="2000" b="0" i="0" u="none" strike="noStrike" kern="1200" cap="none" spc="0" normalizeH="0" baseline="0" noProof="0" dirty="0">
+                <a:ln>
+                  <a:noFill/>
+                </a:ln>
+                <a:solidFill>
+                  <a:prstClr val="black"/>
+                </a:solidFill>
+                <a:effectLst/>
+                <a:uLnTx/>
+                <a:uFillTx/>
+                <a:latin typeface="UT Sans" pitchFamily="50" charset="0"/>
+                <a:ea typeface="+mn-ea"/>
+                <a:cs typeface="+mn-cs"/>
+              </a:rPr>
+              <a:t> ADC-</a:t>
+            </a:r>
+            <a:r>
+              <a:rPr kumimoji="0" lang="en-US" sz="2000" b="0" i="0" u="none" strike="noStrike" kern="1200" cap="none" spc="0" normalizeH="0" baseline="0" noProof="0" dirty="0" err="1">
+                <a:ln>
+                  <a:noFill/>
+                </a:ln>
+                <a:solidFill>
+                  <a:prstClr val="black"/>
+                </a:solidFill>
+                <a:effectLst/>
+                <a:uLnTx/>
+                <a:uFillTx/>
+                <a:latin typeface="UT Sans" pitchFamily="50" charset="0"/>
+                <a:ea typeface="+mn-ea"/>
+                <a:cs typeface="+mn-cs"/>
+              </a:rPr>
+              <a:t>ului</a:t>
+            </a:r>
+            <a:r>
+              <a:rPr kumimoji="0" lang="en-US" sz="2000" b="0" i="0" u="none" strike="noStrike" kern="1200" cap="none" spc="0" normalizeH="0" baseline="0" noProof="0" dirty="0">
+                <a:ln>
+                  <a:noFill/>
+                </a:ln>
+                <a:solidFill>
+                  <a:prstClr val="black"/>
+                </a:solidFill>
+                <a:effectLst/>
+                <a:uLnTx/>
+                <a:uFillTx/>
+                <a:latin typeface="UT Sans" pitchFamily="50" charset="0"/>
+                <a:ea typeface="+mn-ea"/>
+                <a:cs typeface="+mn-cs"/>
+              </a:rPr>
+              <a:t>, </a:t>
+            </a:r>
+            <a:r>
+              <a:rPr kumimoji="0" lang="en-US" sz="2000" b="0" i="0" u="none" strike="noStrike" kern="1200" cap="none" spc="0" normalizeH="0" baseline="0" noProof="0" dirty="0" err="1">
+                <a:ln>
+                  <a:noFill/>
+                </a:ln>
+                <a:solidFill>
+                  <a:prstClr val="black"/>
+                </a:solidFill>
+                <a:effectLst/>
+                <a:uLnTx/>
+                <a:uFillTx/>
+                <a:latin typeface="UT Sans" pitchFamily="50" charset="0"/>
+                <a:ea typeface="+mn-ea"/>
+                <a:cs typeface="+mn-cs"/>
+              </a:rPr>
+              <a:t>limită</a:t>
+            </a:r>
+            <a:r>
+              <a:rPr kumimoji="0" lang="en-US" sz="2000" b="0" i="0" u="none" strike="noStrike" kern="1200" cap="none" spc="0" normalizeH="0" baseline="0" noProof="0" dirty="0">
+                <a:ln>
+                  <a:noFill/>
+                </a:ln>
+                <a:solidFill>
+                  <a:prstClr val="black"/>
+                </a:solidFill>
+                <a:effectLst/>
+                <a:uLnTx/>
+                <a:uFillTx/>
+                <a:latin typeface="UT Sans" pitchFamily="50" charset="0"/>
+                <a:ea typeface="+mn-ea"/>
+                <a:cs typeface="+mn-cs"/>
+              </a:rPr>
+              <a:t> </a:t>
+            </a:r>
+            <a:r>
+              <a:rPr kumimoji="0" lang="en-US" sz="2000" b="0" i="0" u="none" strike="noStrike" kern="1200" cap="none" spc="0" normalizeH="0" baseline="0" noProof="0" dirty="0" err="1">
+                <a:ln>
+                  <a:noFill/>
+                </a:ln>
+                <a:solidFill>
+                  <a:prstClr val="black"/>
+                </a:solidFill>
+                <a:effectLst/>
+                <a:uLnTx/>
+                <a:uFillTx/>
+                <a:latin typeface="UT Sans" pitchFamily="50" charset="0"/>
+                <a:ea typeface="+mn-ea"/>
+                <a:cs typeface="+mn-cs"/>
+              </a:rPr>
+              <a:t>impusă</a:t>
+            </a:r>
+            <a:r>
+              <a:rPr kumimoji="0" lang="en-US" sz="2000" b="0" i="0" u="none" strike="noStrike" kern="1200" cap="none" spc="0" normalizeH="0" baseline="0" noProof="0" dirty="0">
+                <a:ln>
+                  <a:noFill/>
+                </a:ln>
+                <a:solidFill>
+                  <a:prstClr val="black"/>
+                </a:solidFill>
+                <a:effectLst/>
+                <a:uLnTx/>
+                <a:uFillTx/>
+                <a:latin typeface="UT Sans" pitchFamily="50" charset="0"/>
+                <a:ea typeface="+mn-ea"/>
+                <a:cs typeface="+mn-cs"/>
+              </a:rPr>
+              <a:t> de </a:t>
+            </a:r>
+            <a:r>
+              <a:rPr kumimoji="0" lang="en-US" sz="2000" b="0" i="0" u="none" strike="noStrike" kern="1200" cap="none" spc="0" normalizeH="0" baseline="0" noProof="0" dirty="0" err="1">
+                <a:ln>
+                  <a:noFill/>
+                </a:ln>
+                <a:solidFill>
+                  <a:prstClr val="black"/>
+                </a:solidFill>
+                <a:effectLst/>
+                <a:uLnTx/>
+                <a:uFillTx/>
+                <a:latin typeface="UT Sans" pitchFamily="50" charset="0"/>
+                <a:ea typeface="+mn-ea"/>
+                <a:cs typeface="+mn-cs"/>
+              </a:rPr>
+              <a:t>amplificatorul</a:t>
+            </a:r>
+            <a:r>
+              <a:rPr kumimoji="0" lang="en-US" sz="2000" b="0" i="0" u="none" strike="noStrike" kern="1200" cap="none" spc="0" normalizeH="0" baseline="0" noProof="0" dirty="0">
+                <a:ln>
+                  <a:noFill/>
+                </a:ln>
+                <a:solidFill>
+                  <a:prstClr val="black"/>
+                </a:solidFill>
+                <a:effectLst/>
+                <a:uLnTx/>
+                <a:uFillTx/>
+                <a:latin typeface="UT Sans" pitchFamily="50" charset="0"/>
+                <a:ea typeface="+mn-ea"/>
+                <a:cs typeface="+mn-cs"/>
+              </a:rPr>
+              <a:t> de </a:t>
+            </a:r>
+            <a:r>
+              <a:rPr kumimoji="0" lang="en-US" sz="2000" b="0" i="0" u="none" strike="noStrike" kern="1200" cap="none" spc="0" normalizeH="0" baseline="0" noProof="0" dirty="0" err="1">
+                <a:ln>
+                  <a:noFill/>
+                </a:ln>
+                <a:solidFill>
+                  <a:prstClr val="black"/>
+                </a:solidFill>
+                <a:effectLst/>
+                <a:uLnTx/>
+                <a:uFillTx/>
+                <a:latin typeface="UT Sans" pitchFamily="50" charset="0"/>
+                <a:ea typeface="+mn-ea"/>
+                <a:cs typeface="+mn-cs"/>
+              </a:rPr>
+              <a:t>intrare</a:t>
+            </a:r>
+            <a:r>
+              <a:rPr kumimoji="0" lang="en-US" sz="2000" b="0" i="0" u="none" strike="noStrike" kern="1200" cap="none" spc="0" normalizeH="0" baseline="0" noProof="0" dirty="0">
+                <a:ln>
+                  <a:noFill/>
+                </a:ln>
+                <a:solidFill>
+                  <a:prstClr val="black"/>
+                </a:solidFill>
+                <a:effectLst/>
+                <a:uLnTx/>
+                <a:uFillTx/>
+                <a:latin typeface="UT Sans" pitchFamily="50" charset="0"/>
+                <a:ea typeface="+mn-ea"/>
+                <a:cs typeface="+mn-cs"/>
+              </a:rPr>
+              <a:t>)</a:t>
+            </a:r>
+          </a:p>
+          <a:p>
+            <a:pPr marR="0" lvl="0" algn="just" defTabSz="914400" rtl="0" eaLnBrk="1" fontAlgn="auto" latinLnBrk="0" hangingPunct="1">
+              <a:lnSpc>
+                <a:spcPct val="150000"/>
+              </a:lnSpc>
+              <a:spcBef>
+                <a:spcPts val="0"/>
+              </a:spcBef>
+              <a:spcAft>
+                <a:spcPts val="0"/>
+              </a:spcAft>
+              <a:buClrTx/>
+              <a:buSzTx/>
+              <a:tabLst/>
+              <a:defRPr/>
+            </a:pPr>
+            <a:r>
+              <a:rPr kumimoji="0" lang="en-US" sz="2000" b="0" i="0" u="none" strike="noStrike" kern="1200" cap="none" spc="0" normalizeH="0" baseline="0" noProof="0" dirty="0">
+                <a:ln>
+                  <a:noFill/>
+                </a:ln>
+                <a:solidFill>
+                  <a:prstClr val="black"/>
+                </a:solidFill>
+                <a:effectLst/>
+                <a:uLnTx/>
+                <a:uFillTx/>
+                <a:latin typeface="UT Sans" pitchFamily="50" charset="0"/>
+                <a:ea typeface="+mn-ea"/>
+                <a:cs typeface="+mn-cs"/>
+              </a:rPr>
+              <a:t>• </a:t>
+            </a:r>
+            <a:r>
+              <a:rPr kumimoji="0" lang="en-US" sz="2000" b="0" i="0" u="none" strike="noStrike" kern="1200" cap="none" spc="0" normalizeH="0" baseline="0" noProof="0" dirty="0" err="1">
+                <a:ln>
+                  <a:noFill/>
+                </a:ln>
+                <a:solidFill>
+                  <a:prstClr val="black"/>
+                </a:solidFill>
+                <a:effectLst/>
+                <a:uLnTx/>
+                <a:uFillTx/>
+                <a:latin typeface="UT Sans" pitchFamily="50" charset="0"/>
+                <a:ea typeface="+mn-ea"/>
+                <a:cs typeface="+mn-cs"/>
+              </a:rPr>
+              <a:t>Alimentare</a:t>
+            </a:r>
+            <a:r>
+              <a:rPr kumimoji="0" lang="en-US" sz="2000" b="0" i="0" u="none" strike="noStrike" kern="1200" cap="none" spc="0" normalizeH="0" baseline="0" noProof="0" dirty="0">
+                <a:ln>
+                  <a:noFill/>
+                </a:ln>
+                <a:solidFill>
+                  <a:prstClr val="black"/>
+                </a:solidFill>
+                <a:effectLst/>
+                <a:uLnTx/>
+                <a:uFillTx/>
+                <a:latin typeface="UT Sans" pitchFamily="50" charset="0"/>
+                <a:ea typeface="+mn-ea"/>
+                <a:cs typeface="+mn-cs"/>
+              </a:rPr>
+              <a:t> </a:t>
+            </a:r>
+            <a:r>
+              <a:rPr kumimoji="0" lang="en-US" sz="2000" b="0" i="0" u="none" strike="noStrike" kern="1200" cap="none" spc="0" normalizeH="0" baseline="0" noProof="0" dirty="0" err="1">
+                <a:ln>
+                  <a:noFill/>
+                </a:ln>
+                <a:solidFill>
+                  <a:prstClr val="black"/>
+                </a:solidFill>
+                <a:effectLst/>
+                <a:uLnTx/>
+                <a:uFillTx/>
+                <a:latin typeface="UT Sans" pitchFamily="50" charset="0"/>
+                <a:ea typeface="+mn-ea"/>
+                <a:cs typeface="+mn-cs"/>
+              </a:rPr>
+              <a:t>unică</a:t>
+            </a:r>
+            <a:r>
+              <a:rPr kumimoji="0" lang="en-US" sz="2000" b="0" i="0" u="none" strike="noStrike" kern="1200" cap="none" spc="0" normalizeH="0" baseline="0" noProof="0" dirty="0">
+                <a:ln>
+                  <a:noFill/>
+                </a:ln>
+                <a:solidFill>
+                  <a:prstClr val="black"/>
+                </a:solidFill>
+                <a:effectLst/>
+                <a:uLnTx/>
+                <a:uFillTx/>
+                <a:latin typeface="UT Sans" pitchFamily="50" charset="0"/>
+                <a:ea typeface="+mn-ea"/>
+                <a:cs typeface="+mn-cs"/>
+              </a:rPr>
+              <a:t> </a:t>
+            </a:r>
+            <a:r>
+              <a:rPr kumimoji="0" lang="en-US" sz="2000" b="0" i="0" u="none" strike="noStrike" kern="1200" cap="none" spc="0" normalizeH="0" baseline="0" noProof="0" dirty="0" err="1">
+                <a:ln>
+                  <a:noFill/>
+                </a:ln>
+                <a:solidFill>
+                  <a:prstClr val="black"/>
+                </a:solidFill>
+                <a:effectLst/>
+                <a:uLnTx/>
+                <a:uFillTx/>
+                <a:latin typeface="UT Sans" pitchFamily="50" charset="0"/>
+                <a:ea typeface="+mn-ea"/>
+                <a:cs typeface="+mn-cs"/>
+              </a:rPr>
+              <a:t>prin</a:t>
+            </a:r>
+            <a:r>
+              <a:rPr kumimoji="0" lang="en-US" sz="2000" b="0" i="0" u="none" strike="noStrike" kern="1200" cap="none" spc="0" normalizeH="0" baseline="0" noProof="0" dirty="0">
+                <a:ln>
+                  <a:noFill/>
+                </a:ln>
+                <a:solidFill>
+                  <a:prstClr val="black"/>
+                </a:solidFill>
+                <a:effectLst/>
+                <a:uLnTx/>
+                <a:uFillTx/>
+                <a:latin typeface="UT Sans" pitchFamily="50" charset="0"/>
+                <a:ea typeface="+mn-ea"/>
+                <a:cs typeface="+mn-cs"/>
+              </a:rPr>
+              <a:t> USB-C de 5V</a:t>
+            </a:r>
+          </a:p>
+          <a:p>
+            <a:pPr marR="0" lvl="0" algn="just" defTabSz="914400" rtl="0" eaLnBrk="1" fontAlgn="auto" latinLnBrk="0" hangingPunct="1">
+              <a:lnSpc>
+                <a:spcPct val="150000"/>
+              </a:lnSpc>
+              <a:spcBef>
+                <a:spcPts val="0"/>
+              </a:spcBef>
+              <a:spcAft>
+                <a:spcPts val="0"/>
+              </a:spcAft>
+              <a:buClrTx/>
+              <a:buSzTx/>
+              <a:tabLst/>
+              <a:defRPr/>
+            </a:pPr>
+            <a:r>
+              <a:rPr kumimoji="0" lang="en-US" sz="2000" b="0" i="0" u="none" strike="noStrike" kern="1200" cap="none" spc="0" normalizeH="0" baseline="0" noProof="0" dirty="0">
+                <a:ln>
+                  <a:noFill/>
+                </a:ln>
+                <a:solidFill>
+                  <a:prstClr val="black"/>
+                </a:solidFill>
+                <a:effectLst/>
+                <a:uLnTx/>
+                <a:uFillTx/>
+                <a:latin typeface="UT Sans" pitchFamily="50" charset="0"/>
+                <a:ea typeface="+mn-ea"/>
+                <a:cs typeface="+mn-cs"/>
+              </a:rPr>
+              <a:t>• Transfer de date </a:t>
+            </a:r>
+            <a:r>
+              <a:rPr kumimoji="0" lang="en-US" sz="2000" b="0" i="0" u="none" strike="noStrike" kern="1200" cap="none" spc="0" normalizeH="0" baseline="0" noProof="0" dirty="0" err="1">
+                <a:ln>
+                  <a:noFill/>
+                </a:ln>
+                <a:solidFill>
+                  <a:prstClr val="black"/>
+                </a:solidFill>
+                <a:effectLst/>
+                <a:uLnTx/>
+                <a:uFillTx/>
+                <a:latin typeface="UT Sans" pitchFamily="50" charset="0"/>
+                <a:ea typeface="+mn-ea"/>
+                <a:cs typeface="+mn-cs"/>
+              </a:rPr>
+              <a:t>prin</a:t>
+            </a:r>
+            <a:r>
+              <a:rPr kumimoji="0" lang="en-US" sz="2000" b="0" i="0" u="none" strike="noStrike" kern="1200" cap="none" spc="0" normalizeH="0" baseline="0" noProof="0" dirty="0">
+                <a:ln>
+                  <a:noFill/>
+                </a:ln>
+                <a:solidFill>
+                  <a:prstClr val="black"/>
+                </a:solidFill>
+                <a:effectLst/>
+                <a:uLnTx/>
+                <a:uFillTx/>
+                <a:latin typeface="UT Sans" pitchFamily="50" charset="0"/>
+                <a:ea typeface="+mn-ea"/>
+                <a:cs typeface="+mn-cs"/>
+              </a:rPr>
+              <a:t> USB-C (Max. 2Mb/s)</a:t>
+            </a:r>
+          </a:p>
+          <a:p>
+            <a:pPr marR="0" lvl="0" algn="just" defTabSz="914400" rtl="0" eaLnBrk="1" fontAlgn="auto" latinLnBrk="0" hangingPunct="1">
+              <a:lnSpc>
+                <a:spcPct val="150000"/>
+              </a:lnSpc>
+              <a:spcBef>
+                <a:spcPts val="0"/>
+              </a:spcBef>
+              <a:spcAft>
+                <a:spcPts val="0"/>
+              </a:spcAft>
+              <a:buClrTx/>
+              <a:buSzTx/>
+              <a:tabLst/>
+              <a:defRPr/>
+            </a:pPr>
+            <a:r>
+              <a:rPr kumimoji="0" lang="en-US" sz="2000" b="0" i="0" u="none" strike="noStrike" kern="1200" cap="none" spc="0" normalizeH="0" baseline="0" noProof="0" dirty="0">
+                <a:ln>
+                  <a:noFill/>
+                </a:ln>
+                <a:solidFill>
+                  <a:prstClr val="black"/>
+                </a:solidFill>
+                <a:effectLst/>
+                <a:uLnTx/>
+                <a:uFillTx/>
+                <a:latin typeface="UT Sans" pitchFamily="50" charset="0"/>
+                <a:ea typeface="+mn-ea"/>
+                <a:cs typeface="+mn-cs"/>
+              </a:rPr>
+              <a:t>• </a:t>
+            </a:r>
+            <a:r>
+              <a:rPr kumimoji="0" lang="en-US" sz="2000" b="0" i="0" u="none" strike="noStrike" kern="1200" cap="none" spc="0" normalizeH="0" baseline="0" noProof="0" dirty="0" err="1">
+                <a:ln>
+                  <a:noFill/>
+                </a:ln>
+                <a:solidFill>
+                  <a:prstClr val="black"/>
+                </a:solidFill>
+                <a:effectLst/>
+                <a:uLnTx/>
+                <a:uFillTx/>
+                <a:latin typeface="UT Sans" pitchFamily="50" charset="0"/>
+                <a:ea typeface="+mn-ea"/>
+                <a:cs typeface="+mn-cs"/>
+              </a:rPr>
+              <a:t>Intrare</a:t>
+            </a:r>
+            <a:r>
+              <a:rPr kumimoji="0" lang="en-US" sz="2000" b="0" i="0" u="none" strike="noStrike" kern="1200" cap="none" spc="0" normalizeH="0" baseline="0" noProof="0" dirty="0">
+                <a:ln>
+                  <a:noFill/>
+                </a:ln>
+                <a:solidFill>
+                  <a:prstClr val="black"/>
+                </a:solidFill>
+                <a:effectLst/>
+                <a:uLnTx/>
+                <a:uFillTx/>
+                <a:latin typeface="UT Sans" pitchFamily="50" charset="0"/>
+                <a:ea typeface="+mn-ea"/>
+                <a:cs typeface="+mn-cs"/>
+              </a:rPr>
+              <a:t> BNC</a:t>
+            </a:r>
+          </a:p>
+          <a:p>
+            <a:pPr marR="0" lvl="0" algn="just" defTabSz="914400" rtl="0" eaLnBrk="1" fontAlgn="auto" latinLnBrk="0" hangingPunct="1">
+              <a:lnSpc>
+                <a:spcPct val="150000"/>
+              </a:lnSpc>
+              <a:spcBef>
+                <a:spcPts val="0"/>
+              </a:spcBef>
+              <a:spcAft>
+                <a:spcPts val="0"/>
+              </a:spcAft>
+              <a:buClrTx/>
+              <a:buSzTx/>
+              <a:tabLst/>
+              <a:defRPr/>
+            </a:pPr>
+            <a:r>
+              <a:rPr kumimoji="0" lang="en-US" sz="2000" b="0" i="0" u="none" strike="noStrike" kern="1200" cap="none" spc="0" normalizeH="0" baseline="0" noProof="0" dirty="0">
+                <a:ln>
+                  <a:noFill/>
+                </a:ln>
+                <a:solidFill>
+                  <a:prstClr val="black"/>
+                </a:solidFill>
+                <a:effectLst/>
+                <a:uLnTx/>
+                <a:uFillTx/>
+                <a:latin typeface="UT Sans" pitchFamily="50" charset="0"/>
+                <a:ea typeface="+mn-ea"/>
+                <a:cs typeface="+mn-cs"/>
+              </a:rPr>
+              <a:t>• </a:t>
+            </a:r>
+            <a:r>
+              <a:rPr kumimoji="0" lang="en-US" sz="2000" b="0" i="0" u="none" strike="noStrike" kern="1200" cap="none" spc="0" normalizeH="0" baseline="0" noProof="0" dirty="0" err="1">
+                <a:ln>
+                  <a:noFill/>
+                </a:ln>
+                <a:solidFill>
+                  <a:prstClr val="black"/>
+                </a:solidFill>
+                <a:effectLst/>
+                <a:uLnTx/>
+                <a:uFillTx/>
+                <a:latin typeface="UT Sans" pitchFamily="50" charset="0"/>
+                <a:ea typeface="+mn-ea"/>
+                <a:cs typeface="+mn-cs"/>
+              </a:rPr>
+              <a:t>Cuplaj</a:t>
+            </a:r>
+            <a:r>
+              <a:rPr kumimoji="0" lang="en-US" sz="2000" b="0" i="0" u="none" strike="noStrike" kern="1200" cap="none" spc="0" normalizeH="0" baseline="0" noProof="0" dirty="0">
+                <a:ln>
+                  <a:noFill/>
+                </a:ln>
+                <a:solidFill>
+                  <a:prstClr val="black"/>
+                </a:solidFill>
+                <a:effectLst/>
+                <a:uLnTx/>
+                <a:uFillTx/>
+                <a:latin typeface="UT Sans" pitchFamily="50" charset="0"/>
+                <a:ea typeface="+mn-ea"/>
+                <a:cs typeface="+mn-cs"/>
+              </a:rPr>
+              <a:t> AC/DC</a:t>
+            </a:r>
+          </a:p>
+          <a:p>
+            <a:pPr marR="0" lvl="0" algn="just" defTabSz="914400" rtl="0" eaLnBrk="1" fontAlgn="auto" latinLnBrk="0" hangingPunct="1">
+              <a:lnSpc>
+                <a:spcPct val="150000"/>
+              </a:lnSpc>
+              <a:spcBef>
+                <a:spcPts val="0"/>
+              </a:spcBef>
+              <a:spcAft>
+                <a:spcPts val="0"/>
+              </a:spcAft>
+              <a:buClrTx/>
+              <a:buSzTx/>
+              <a:tabLst/>
+              <a:defRPr/>
+            </a:pPr>
+            <a:r>
+              <a:rPr kumimoji="0" lang="en-US" sz="2000" b="0" i="0" u="none" strike="noStrike" kern="1200" cap="none" spc="0" normalizeH="0" baseline="0" noProof="0" dirty="0">
+                <a:ln>
+                  <a:noFill/>
+                </a:ln>
+                <a:solidFill>
+                  <a:prstClr val="black"/>
+                </a:solidFill>
+                <a:effectLst/>
+                <a:uLnTx/>
+                <a:uFillTx/>
+                <a:latin typeface="UT Sans" pitchFamily="50" charset="0"/>
+                <a:ea typeface="+mn-ea"/>
+                <a:cs typeface="+mn-cs"/>
+              </a:rPr>
+              <a:t>• </a:t>
+            </a:r>
+            <a:r>
+              <a:rPr kumimoji="0" lang="en-US" sz="2000" b="0" i="0" u="none" strike="noStrike" kern="1200" cap="none" spc="0" normalizeH="0" baseline="0" noProof="0" dirty="0" err="1">
+                <a:ln>
+                  <a:noFill/>
+                </a:ln>
+                <a:solidFill>
+                  <a:prstClr val="black"/>
+                </a:solidFill>
+                <a:effectLst/>
+                <a:uLnTx/>
+                <a:uFillTx/>
+                <a:latin typeface="UT Sans" pitchFamily="50" charset="0"/>
+                <a:ea typeface="+mn-ea"/>
+                <a:cs typeface="+mn-cs"/>
+              </a:rPr>
+              <a:t>Encodere</a:t>
+            </a:r>
+            <a:r>
+              <a:rPr kumimoji="0" lang="en-US" sz="2000" b="0" i="0" u="none" strike="noStrike" kern="1200" cap="none" spc="0" normalizeH="0" baseline="0" noProof="0" dirty="0">
+                <a:ln>
+                  <a:noFill/>
+                </a:ln>
+                <a:solidFill>
+                  <a:prstClr val="black"/>
+                </a:solidFill>
+                <a:effectLst/>
+                <a:uLnTx/>
+                <a:uFillTx/>
+                <a:latin typeface="UT Sans" pitchFamily="50" charset="0"/>
+                <a:ea typeface="+mn-ea"/>
+                <a:cs typeface="+mn-cs"/>
+              </a:rPr>
+              <a:t> </a:t>
+            </a:r>
+            <a:r>
+              <a:rPr kumimoji="0" lang="en-US" sz="2000" b="0" i="0" u="none" strike="noStrike" kern="1200" cap="none" spc="0" normalizeH="0" baseline="0" noProof="0" dirty="0" err="1">
+                <a:ln>
+                  <a:noFill/>
+                </a:ln>
+                <a:solidFill>
+                  <a:prstClr val="black"/>
+                </a:solidFill>
+                <a:effectLst/>
+                <a:uLnTx/>
+                <a:uFillTx/>
+                <a:latin typeface="UT Sans" pitchFamily="50" charset="0"/>
+                <a:ea typeface="+mn-ea"/>
+                <a:cs typeface="+mn-cs"/>
+              </a:rPr>
+              <a:t>digitale</a:t>
+            </a:r>
+            <a:r>
+              <a:rPr kumimoji="0" lang="en-US" sz="2000" b="0" i="0" u="none" strike="noStrike" kern="1200" cap="none" spc="0" normalizeH="0" baseline="0" noProof="0" dirty="0">
+                <a:ln>
+                  <a:noFill/>
+                </a:ln>
+                <a:solidFill>
+                  <a:prstClr val="black"/>
+                </a:solidFill>
+                <a:effectLst/>
+                <a:uLnTx/>
+                <a:uFillTx/>
+                <a:latin typeface="UT Sans" pitchFamily="50" charset="0"/>
+                <a:ea typeface="+mn-ea"/>
+                <a:cs typeface="+mn-cs"/>
+              </a:rPr>
+              <a:t> </a:t>
+            </a:r>
+            <a:r>
+              <a:rPr kumimoji="0" lang="en-US" sz="2000" b="0" i="0" u="none" strike="noStrike" kern="1200" cap="none" spc="0" normalizeH="0" baseline="0" noProof="0" dirty="0" err="1">
+                <a:ln>
+                  <a:noFill/>
+                </a:ln>
+                <a:solidFill>
+                  <a:prstClr val="black"/>
+                </a:solidFill>
+                <a:effectLst/>
+                <a:uLnTx/>
+                <a:uFillTx/>
+                <a:latin typeface="UT Sans" pitchFamily="50" charset="0"/>
+                <a:ea typeface="+mn-ea"/>
+                <a:cs typeface="+mn-cs"/>
+              </a:rPr>
+              <a:t>pentru</a:t>
+            </a:r>
+            <a:r>
+              <a:rPr kumimoji="0" lang="en-US" sz="2000" b="0" i="0" u="none" strike="noStrike" kern="1200" cap="none" spc="0" normalizeH="0" baseline="0" noProof="0" dirty="0">
+                <a:ln>
+                  <a:noFill/>
+                </a:ln>
+                <a:solidFill>
+                  <a:prstClr val="black"/>
+                </a:solidFill>
+                <a:effectLst/>
+                <a:uLnTx/>
+                <a:uFillTx/>
+                <a:latin typeface="UT Sans" pitchFamily="50" charset="0"/>
+                <a:ea typeface="+mn-ea"/>
+                <a:cs typeface="+mn-cs"/>
+              </a:rPr>
+              <a:t> control al </a:t>
+            </a:r>
+            <a:r>
+              <a:rPr kumimoji="0" lang="en-US" sz="2000" b="0" i="0" u="none" strike="noStrike" kern="1200" cap="none" spc="0" normalizeH="0" baseline="0" noProof="0" dirty="0" err="1">
+                <a:ln>
+                  <a:noFill/>
+                </a:ln>
+                <a:solidFill>
+                  <a:prstClr val="black"/>
+                </a:solidFill>
+                <a:effectLst/>
+                <a:uLnTx/>
+                <a:uFillTx/>
+                <a:latin typeface="UT Sans" pitchFamily="50" charset="0"/>
+                <a:ea typeface="+mn-ea"/>
+                <a:cs typeface="+mn-cs"/>
+              </a:rPr>
+              <a:t>afișajului</a:t>
+            </a:r>
+            <a:r>
+              <a:rPr kumimoji="0" lang="en-US" sz="2000" b="0" i="0" u="none" strike="noStrike" kern="1200" cap="none" spc="0" normalizeH="0" baseline="0" noProof="0" dirty="0">
+                <a:ln>
+                  <a:noFill/>
+                </a:ln>
+                <a:solidFill>
+                  <a:prstClr val="black"/>
+                </a:solidFill>
+                <a:effectLst/>
+                <a:uLnTx/>
+                <a:uFillTx/>
+                <a:latin typeface="UT Sans" pitchFamily="50" charset="0"/>
+                <a:ea typeface="+mn-ea"/>
+                <a:cs typeface="+mn-cs"/>
+              </a:rPr>
+              <a:t> (</a:t>
+            </a:r>
+            <a:r>
+              <a:rPr kumimoji="0" lang="en-US" sz="2000" b="0" i="0" u="none" strike="noStrike" kern="1200" cap="none" spc="0" normalizeH="0" baseline="0" noProof="0" dirty="0" err="1">
+                <a:ln>
+                  <a:noFill/>
+                </a:ln>
+                <a:solidFill>
+                  <a:prstClr val="black"/>
+                </a:solidFill>
+                <a:effectLst/>
+                <a:uLnTx/>
+                <a:uFillTx/>
+                <a:latin typeface="UT Sans" pitchFamily="50" charset="0"/>
+                <a:ea typeface="+mn-ea"/>
+                <a:cs typeface="+mn-cs"/>
+              </a:rPr>
+              <a:t>baza</a:t>
+            </a:r>
+            <a:r>
+              <a:rPr kumimoji="0" lang="en-US" sz="2000" b="0" i="0" u="none" strike="noStrike" kern="1200" cap="none" spc="0" normalizeH="0" baseline="0" noProof="0" dirty="0">
+                <a:ln>
+                  <a:noFill/>
+                </a:ln>
+                <a:solidFill>
+                  <a:prstClr val="black"/>
+                </a:solidFill>
+                <a:effectLst/>
+                <a:uLnTx/>
+                <a:uFillTx/>
+                <a:latin typeface="UT Sans" pitchFamily="50" charset="0"/>
+                <a:ea typeface="+mn-ea"/>
+                <a:cs typeface="+mn-cs"/>
+              </a:rPr>
+              <a:t> de </a:t>
+            </a:r>
+            <a:r>
+              <a:rPr kumimoji="0" lang="en-US" sz="2000" b="0" i="0" u="none" strike="noStrike" kern="1200" cap="none" spc="0" normalizeH="0" baseline="0" noProof="0" dirty="0" err="1">
+                <a:ln>
+                  <a:noFill/>
+                </a:ln>
+                <a:solidFill>
+                  <a:prstClr val="black"/>
+                </a:solidFill>
+                <a:effectLst/>
+                <a:uLnTx/>
+                <a:uFillTx/>
+                <a:latin typeface="UT Sans" pitchFamily="50" charset="0"/>
+                <a:ea typeface="+mn-ea"/>
+                <a:cs typeface="+mn-cs"/>
+              </a:rPr>
+              <a:t>timp</a:t>
+            </a:r>
+            <a:r>
+              <a:rPr kumimoji="0" lang="en-US" sz="2000" b="0" i="0" u="none" strike="noStrike" kern="1200" cap="none" spc="0" normalizeH="0" baseline="0" noProof="0" dirty="0">
+                <a:ln>
+                  <a:noFill/>
+                </a:ln>
+                <a:solidFill>
+                  <a:prstClr val="black"/>
+                </a:solidFill>
+                <a:effectLst/>
+                <a:uLnTx/>
+                <a:uFillTx/>
+                <a:latin typeface="UT Sans" pitchFamily="50" charset="0"/>
+                <a:ea typeface="+mn-ea"/>
+                <a:cs typeface="+mn-cs"/>
+              </a:rPr>
+              <a:t> </a:t>
+            </a:r>
+            <a:r>
+              <a:rPr kumimoji="0" lang="en-US" sz="2000" b="0" i="0" u="none" strike="noStrike" kern="1200" cap="none" spc="0" normalizeH="0" baseline="0" noProof="0" dirty="0" err="1">
+                <a:ln>
+                  <a:noFill/>
+                </a:ln>
+                <a:solidFill>
+                  <a:prstClr val="black"/>
+                </a:solidFill>
+                <a:effectLst/>
+                <a:uLnTx/>
+                <a:uFillTx/>
+                <a:latin typeface="UT Sans" pitchFamily="50" charset="0"/>
+                <a:ea typeface="+mn-ea"/>
+                <a:cs typeface="+mn-cs"/>
+              </a:rPr>
+              <a:t>și</a:t>
+            </a:r>
+            <a:r>
+              <a:rPr kumimoji="0" lang="en-US" sz="2000" b="0" i="0" u="none" strike="noStrike" kern="1200" cap="none" spc="0" normalizeH="0" baseline="0" noProof="0" dirty="0">
+                <a:ln>
+                  <a:noFill/>
+                </a:ln>
+                <a:solidFill>
+                  <a:prstClr val="black"/>
+                </a:solidFill>
+                <a:effectLst/>
+                <a:uLnTx/>
+                <a:uFillTx/>
+                <a:latin typeface="UT Sans" pitchFamily="50" charset="0"/>
+                <a:ea typeface="+mn-ea"/>
+                <a:cs typeface="+mn-cs"/>
+              </a:rPr>
+              <a:t> </a:t>
+            </a:r>
+            <a:r>
+              <a:rPr kumimoji="0" lang="en-US" sz="2000" b="0" i="0" u="none" strike="noStrike" kern="1200" cap="none" spc="0" normalizeH="0" baseline="0" noProof="0" dirty="0" err="1">
+                <a:ln>
+                  <a:noFill/>
+                </a:ln>
+                <a:solidFill>
+                  <a:prstClr val="black"/>
+                </a:solidFill>
+                <a:effectLst/>
+                <a:uLnTx/>
+                <a:uFillTx/>
+                <a:latin typeface="UT Sans" pitchFamily="50" charset="0"/>
+                <a:ea typeface="+mn-ea"/>
+                <a:cs typeface="+mn-cs"/>
+              </a:rPr>
+              <a:t>scară</a:t>
+            </a:r>
+            <a:r>
+              <a:rPr kumimoji="0" lang="en-US" sz="2000" b="0" i="0" u="none" strike="noStrike" kern="1200" cap="none" spc="0" normalizeH="0" baseline="0" noProof="0" dirty="0">
+                <a:ln>
+                  <a:noFill/>
+                </a:ln>
+                <a:solidFill>
+                  <a:prstClr val="black"/>
+                </a:solidFill>
+                <a:effectLst/>
+                <a:uLnTx/>
+                <a:uFillTx/>
+                <a:latin typeface="UT Sans" pitchFamily="50" charset="0"/>
+                <a:ea typeface="+mn-ea"/>
+                <a:cs typeface="+mn-cs"/>
+              </a:rPr>
+              <a:t> de </a:t>
+            </a:r>
+            <a:r>
+              <a:rPr kumimoji="0" lang="en-US" sz="2000" b="0" i="0" u="none" strike="noStrike" kern="1200" cap="none" spc="0" normalizeH="0" baseline="0" noProof="0" dirty="0" err="1">
+                <a:ln>
+                  <a:noFill/>
+                </a:ln>
+                <a:solidFill>
+                  <a:prstClr val="black"/>
+                </a:solidFill>
+                <a:effectLst/>
+                <a:uLnTx/>
+                <a:uFillTx/>
+                <a:latin typeface="UT Sans" pitchFamily="50" charset="0"/>
+                <a:ea typeface="+mn-ea"/>
+                <a:cs typeface="+mn-cs"/>
+              </a:rPr>
+              <a:t>tensiune</a:t>
+            </a:r>
+            <a:r>
+              <a:rPr kumimoji="0" lang="en-US" sz="2000" b="0" i="0" u="none" strike="noStrike" kern="1200" cap="none" spc="0" normalizeH="0" baseline="0" noProof="0" dirty="0">
+                <a:ln>
+                  <a:noFill/>
+                </a:ln>
+                <a:solidFill>
+                  <a:prstClr val="black"/>
+                </a:solidFill>
+                <a:effectLst/>
+                <a:uLnTx/>
+                <a:uFillTx/>
+                <a:latin typeface="UT Sans" pitchFamily="50" charset="0"/>
+                <a:ea typeface="+mn-ea"/>
+                <a:cs typeface="+mn-cs"/>
+              </a:rPr>
+              <a:t>)</a:t>
+            </a:r>
+          </a:p>
+        </p:txBody>
+      </p:sp>
+      <p:pic>
+        <p:nvPicPr>
+          <p:cNvPr id="2" name="Picture 1"/>
+          <p:cNvPicPr>
+            <a:picLocks noChangeAspect="1"/>
+          </p:cNvPicPr>
+          <p:nvPr/>
+        </p:nvPicPr>
+        <p:blipFill>
+          <a:blip r:embed="rId2" cstate="print">
+            <a:extLst>
+              <a:ext uri="{28A0092B-C50C-407E-A947-70E740481C1C}">
+                <a14:useLocalDpi xmlns:a14="http://schemas.microsoft.com/office/drawing/2010/main" val="0"/>
+              </a:ext>
+            </a:extLst>
+          </a:blip>
+          <a:stretch>
+            <a:fillRect/>
+          </a:stretch>
+        </p:blipFill>
+        <p:spPr>
+          <a:xfrm>
+            <a:off x="359532" y="341671"/>
+            <a:ext cx="1944216" cy="531045"/>
+          </a:xfrm>
+          <a:prstGeom prst="rect">
+            <a:avLst/>
+          </a:prstGeom>
+        </p:spPr>
+      </p:pic>
+      <p:sp>
+        <p:nvSpPr>
+          <p:cNvPr id="9" name="TextBox 8">
+            <a:extLst>
+              <a:ext uri="{FF2B5EF4-FFF2-40B4-BE49-F238E27FC236}">
+                <a16:creationId xmlns:a16="http://schemas.microsoft.com/office/drawing/2014/main" id="{569E954C-8956-D007-11B6-AB54FF84615A}"/>
+              </a:ext>
+            </a:extLst>
+          </p:cNvPr>
+          <p:cNvSpPr txBox="1"/>
+          <p:nvPr/>
+        </p:nvSpPr>
+        <p:spPr>
+          <a:xfrm>
+            <a:off x="3095836" y="512676"/>
+            <a:ext cx="5310590" cy="400110"/>
+          </a:xfrm>
+          <a:prstGeom prst="rect">
+            <a:avLst/>
+          </a:prstGeom>
+          <a:noFill/>
+        </p:spPr>
+        <p:txBody>
+          <a:bodyPr wrap="square" rtlCol="0">
+            <a:spAutoFit/>
+          </a:bodyPr>
+          <a:lstStyle/>
+          <a:p>
+            <a:pPr algn="r"/>
+            <a:r>
+              <a:rPr lang="ro-RO" sz="2000" dirty="0"/>
+              <a:t>Specificații hardware finale</a:t>
+            </a:r>
+          </a:p>
+        </p:txBody>
+      </p:sp>
+    </p:spTree>
+    <p:extLst>
+      <p:ext uri="{BB962C8B-B14F-4D97-AF65-F5344CB8AC3E}">
+        <p14:creationId xmlns:p14="http://schemas.microsoft.com/office/powerpoint/2010/main" val="4277757765"/>
+      </p:ext>
+    </p:extLst>
+  </p:cSld>
+  <p:clrMapOvr>
+    <a:masterClrMapping/>
+  </p:clrMapOvr>
+</p:sld>
+</file>
+
+<file path=ppt/slides/slide7.xml><?xml version="1.0" encoding="utf-8"?>
+<p:sld xmlns:a="http://schemas.openxmlformats.org/drawingml/2006/main" xmlns:r="http://schemas.openxmlformats.org/officeDocument/2006/relationships" xmlns:p="http://schemas.openxmlformats.org/presentationml/2006/main">
+  <p:cSld>
+    <p:spTree>
+      <p:nvGrpSpPr>
+        <p:cNvPr id="1" name=""/>
+        <p:cNvGrpSpPr/>
+        <p:nvPr/>
+      </p:nvGrpSpPr>
+      <p:grpSpPr>
+        <a:xfrm>
+          <a:off x="0" y="0"/>
+          <a:ext cx="0" cy="0"/>
+          <a:chOff x="0" y="0"/>
+          <a:chExt cx="0" cy="0"/>
+        </a:xfrm>
+      </p:grpSpPr>
+      <p:grpSp>
+        <p:nvGrpSpPr>
+          <p:cNvPr id="4" name="Group 3"/>
+          <p:cNvGrpSpPr/>
+          <p:nvPr/>
+        </p:nvGrpSpPr>
+        <p:grpSpPr>
+          <a:xfrm>
+            <a:off x="8460432" y="6237312"/>
+            <a:ext cx="216000" cy="216000"/>
+            <a:chOff x="2772000" y="1932221"/>
+            <a:chExt cx="2340000" cy="2340000"/>
+          </a:xfrm>
+        </p:grpSpPr>
+        <p:sp>
+          <p:nvSpPr>
+            <p:cNvPr id="5" name="Rectangle 4"/>
+            <p:cNvSpPr/>
+            <p:nvPr/>
+          </p:nvSpPr>
+          <p:spPr>
+            <a:xfrm>
+              <a:off x="2772000" y="1932221"/>
+              <a:ext cx="2340000" cy="2340000"/>
+            </a:xfrm>
+            <a:prstGeom prst="rect">
+              <a:avLst/>
+            </a:prstGeom>
+            <a:solidFill>
+              <a:schemeClr val="bg1">
+                <a:lumMod val="75000"/>
+              </a:schemeClr>
+            </a:solidFill>
+            <a:ln>
+              <a:noFill/>
+            </a:ln>
+          </p:spPr>
+          <p:style>
+            <a:lnRef idx="2">
+              <a:schemeClr val="accent1">
+                <a:shade val="50000"/>
+              </a:schemeClr>
+            </a:lnRef>
+            <a:fillRef idx="1">
+              <a:schemeClr val="accent1"/>
+            </a:fillRef>
+            <a:effectRef idx="0">
+              <a:schemeClr val="accent1"/>
+            </a:effectRef>
+            <a:fontRef idx="minor">
+              <a:schemeClr val="lt1"/>
+            </a:fontRef>
+          </p:style>
+          <p:txBody>
+            <a:bodyPr rtlCol="0" anchor="ctr"/>
+            <a:lstStyle/>
+            <a:p>
+              <a:pPr marL="0" marR="0" lvl="0" indent="0" algn="ctr" defTabSz="914400" rtl="0" eaLnBrk="1" fontAlgn="auto" latinLnBrk="0" hangingPunct="1">
+                <a:lnSpc>
+                  <a:spcPct val="100000"/>
+                </a:lnSpc>
+                <a:spcBef>
+                  <a:spcPts val="0"/>
+                </a:spcBef>
+                <a:spcAft>
+                  <a:spcPts val="0"/>
+                </a:spcAft>
+                <a:buClrTx/>
+                <a:buSzTx/>
+                <a:buFontTx/>
+                <a:buNone/>
+                <a:tabLst/>
+                <a:defRPr/>
+              </a:pPr>
+              <a:endParaRPr kumimoji="0" lang="en-US" sz="1800" b="0" i="0" u="none" strike="noStrike" kern="1200" cap="none" spc="0" normalizeH="0" baseline="0" noProof="0">
+                <a:ln>
+                  <a:solidFill>
+                    <a:srgbClr val="E7E6E6">
+                      <a:lumMod val="75000"/>
+                    </a:srgbClr>
+                  </a:solidFill>
+                </a:ln>
+                <a:solidFill>
+                  <a:prstClr val="black"/>
+                </a:solidFill>
+                <a:effectLst/>
+                <a:uLnTx/>
+                <a:uFillTx/>
+                <a:latin typeface="Calibri" panose="020F0502020204030204"/>
+                <a:ea typeface="+mn-ea"/>
+                <a:cs typeface="+mn-cs"/>
+              </a:endParaRPr>
+            </a:p>
+          </p:txBody>
+        </p:sp>
+        <p:sp>
+          <p:nvSpPr>
+            <p:cNvPr id="6" name="Rectangle 5"/>
+            <p:cNvSpPr/>
+            <p:nvPr/>
+          </p:nvSpPr>
+          <p:spPr>
+            <a:xfrm>
+              <a:off x="3546000" y="2706221"/>
+              <a:ext cx="792000" cy="792000"/>
+            </a:xfrm>
+            <a:prstGeom prst="rect">
+              <a:avLst/>
+            </a:prstGeom>
+            <a:solidFill>
+              <a:schemeClr val="bg1"/>
+            </a:solidFill>
+            <a:ln>
+              <a:noFill/>
+            </a:ln>
+          </p:spPr>
+          <p:style>
+            <a:lnRef idx="2">
+              <a:schemeClr val="accent1">
+                <a:shade val="50000"/>
+              </a:schemeClr>
+            </a:lnRef>
+            <a:fillRef idx="1">
+              <a:schemeClr val="accent1"/>
+            </a:fillRef>
+            <a:effectRef idx="0">
+              <a:schemeClr val="accent1"/>
+            </a:effectRef>
+            <a:fontRef idx="minor">
+              <a:schemeClr val="lt1"/>
+            </a:fontRef>
+          </p:style>
+          <p:txBody>
+            <a:bodyPr rtlCol="0" anchor="ctr"/>
+            <a:lstStyle/>
+            <a:p>
+              <a:pPr marL="0" marR="0" lvl="0" indent="0" algn="ctr" defTabSz="914400" rtl="0" eaLnBrk="1" fontAlgn="auto" latinLnBrk="0" hangingPunct="1">
+                <a:lnSpc>
+                  <a:spcPct val="100000"/>
+                </a:lnSpc>
+                <a:spcBef>
+                  <a:spcPts val="0"/>
+                </a:spcBef>
+                <a:spcAft>
+                  <a:spcPts val="0"/>
+                </a:spcAft>
+                <a:buClrTx/>
+                <a:buSzTx/>
+                <a:buFontTx/>
+                <a:buNone/>
+                <a:tabLst/>
+                <a:defRPr/>
+              </a:pPr>
+              <a:endParaRPr kumimoji="0" lang="en-US" sz="1800" b="0" i="0" u="none" strike="noStrike" kern="1200" cap="none" spc="0" normalizeH="0" baseline="0" noProof="0">
+                <a:ln>
+                  <a:solidFill>
+                    <a:srgbClr val="E7E6E6">
+                      <a:lumMod val="75000"/>
+                    </a:srgbClr>
+                  </a:solidFill>
+                </a:ln>
+                <a:solidFill>
+                  <a:prstClr val="black"/>
+                </a:solidFill>
+                <a:effectLst/>
+                <a:uLnTx/>
+                <a:uFillTx/>
+                <a:latin typeface="Calibri" panose="020F0502020204030204"/>
+                <a:ea typeface="+mn-ea"/>
+                <a:cs typeface="+mn-cs"/>
+              </a:endParaRPr>
+            </a:p>
+          </p:txBody>
+        </p:sp>
+      </p:grpSp>
+      <p:sp>
+        <p:nvSpPr>
+          <p:cNvPr id="7" name="TextBox 6"/>
+          <p:cNvSpPr txBox="1"/>
+          <p:nvPr/>
+        </p:nvSpPr>
+        <p:spPr>
+          <a:xfrm>
+            <a:off x="611560" y="1044019"/>
+            <a:ext cx="7848872" cy="3747180"/>
+          </a:xfrm>
+          <a:prstGeom prst="rect">
+            <a:avLst/>
+          </a:prstGeom>
+          <a:noFill/>
+        </p:spPr>
+        <p:txBody>
+          <a:bodyPr wrap="square" rtlCol="0">
+            <a:spAutoFit/>
+          </a:bodyPr>
+          <a:lstStyle/>
+          <a:p>
+            <a:pPr marR="0" lvl="0" algn="just" defTabSz="914400" rtl="0" eaLnBrk="1" fontAlgn="auto" latinLnBrk="0" hangingPunct="1">
+              <a:lnSpc>
+                <a:spcPct val="150000"/>
+              </a:lnSpc>
+              <a:spcBef>
+                <a:spcPts val="0"/>
+              </a:spcBef>
+              <a:spcAft>
+                <a:spcPts val="0"/>
+              </a:spcAft>
+              <a:buClrTx/>
+              <a:buSzTx/>
+              <a:tabLst/>
+              <a:defRPr/>
+            </a:pPr>
+            <a:r>
+              <a:rPr kumimoji="0" lang="en-US" sz="2000" b="0" i="0" u="none" strike="noStrike" kern="1200" cap="none" spc="0" normalizeH="0" baseline="0" noProof="0" dirty="0">
+                <a:ln>
+                  <a:noFill/>
+                </a:ln>
+                <a:solidFill>
+                  <a:prstClr val="black"/>
+                </a:solidFill>
+                <a:effectLst/>
+                <a:uLnTx/>
+                <a:uFillTx/>
+                <a:latin typeface="UT Sans" pitchFamily="50" charset="0"/>
+                <a:ea typeface="+mn-ea"/>
+                <a:cs typeface="+mn-cs"/>
+              </a:rPr>
+              <a:t>• </a:t>
+            </a:r>
+            <a:r>
+              <a:rPr kumimoji="0" lang="ro-RO" sz="2000" b="0" i="0" u="none" strike="noStrike" kern="1200" cap="none" spc="0" normalizeH="0" baseline="0" noProof="0" dirty="0">
+                <a:ln>
+                  <a:noFill/>
+                </a:ln>
+                <a:solidFill>
+                  <a:prstClr val="black"/>
+                </a:solidFill>
+                <a:effectLst/>
+                <a:uLnTx/>
+                <a:uFillTx/>
+                <a:latin typeface="UT Sans" pitchFamily="50" charset="0"/>
+                <a:ea typeface="+mn-ea"/>
+                <a:cs typeface="+mn-cs"/>
+              </a:rPr>
+              <a:t>Modularitate hardware și software, posibilitatea de reconfigurare a oricărui parametru și de adăugare a unor funcționalități noi prin pinii GPIO</a:t>
+            </a:r>
+            <a:endParaRPr kumimoji="0" lang="en-US" sz="2000" b="0" i="0" u="none" strike="noStrike" kern="1200" cap="none" spc="0" normalizeH="0" baseline="0" noProof="0" dirty="0">
+              <a:ln>
+                <a:noFill/>
+              </a:ln>
+              <a:solidFill>
+                <a:prstClr val="black"/>
+              </a:solidFill>
+              <a:effectLst/>
+              <a:uLnTx/>
+              <a:uFillTx/>
+              <a:latin typeface="UT Sans" pitchFamily="50" charset="0"/>
+              <a:ea typeface="+mn-ea"/>
+              <a:cs typeface="+mn-cs"/>
+            </a:endParaRPr>
+          </a:p>
+          <a:p>
+            <a:pPr marR="0" lvl="0" algn="just" defTabSz="914400" rtl="0" eaLnBrk="1" fontAlgn="auto" latinLnBrk="0" hangingPunct="1">
+              <a:lnSpc>
+                <a:spcPct val="150000"/>
+              </a:lnSpc>
+              <a:spcBef>
+                <a:spcPts val="0"/>
+              </a:spcBef>
+              <a:spcAft>
+                <a:spcPts val="0"/>
+              </a:spcAft>
+              <a:buClrTx/>
+              <a:buSzTx/>
+              <a:tabLst/>
+              <a:defRPr/>
+            </a:pPr>
+            <a:r>
+              <a:rPr kumimoji="0" lang="en-US" sz="2000" b="0" i="0" u="none" strike="noStrike" kern="1200" cap="none" spc="0" normalizeH="0" baseline="0" noProof="0" dirty="0">
+                <a:ln>
+                  <a:noFill/>
+                </a:ln>
+                <a:solidFill>
+                  <a:prstClr val="black"/>
+                </a:solidFill>
+                <a:effectLst/>
+                <a:uLnTx/>
+                <a:uFillTx/>
+                <a:latin typeface="UT Sans" pitchFamily="50" charset="0"/>
+                <a:ea typeface="+mn-ea"/>
+                <a:cs typeface="+mn-cs"/>
+              </a:rPr>
+              <a:t>• </a:t>
+            </a:r>
+            <a:r>
+              <a:rPr kumimoji="0" lang="ro-RO" sz="2000" b="0" i="0" u="none" strike="noStrike" kern="1200" cap="none" spc="0" normalizeH="0" baseline="0" noProof="0" dirty="0">
+                <a:ln>
+                  <a:noFill/>
+                </a:ln>
+                <a:solidFill>
+                  <a:prstClr val="black"/>
+                </a:solidFill>
+                <a:effectLst/>
+                <a:uLnTx/>
+                <a:uFillTx/>
+                <a:latin typeface="UT Sans" pitchFamily="50" charset="0"/>
+                <a:ea typeface="+mn-ea"/>
+                <a:cs typeface="+mn-cs"/>
+              </a:rPr>
+              <a:t>Consum energetic estimativ maxim mai mic de 2W</a:t>
+            </a:r>
+            <a:endParaRPr kumimoji="0" lang="en-US" sz="2000" b="0" i="0" u="none" strike="noStrike" kern="1200" cap="none" spc="0" normalizeH="0" baseline="0" noProof="0" dirty="0">
+              <a:ln>
+                <a:noFill/>
+              </a:ln>
+              <a:solidFill>
+                <a:prstClr val="black"/>
+              </a:solidFill>
+              <a:effectLst/>
+              <a:uLnTx/>
+              <a:uFillTx/>
+              <a:latin typeface="UT Sans" pitchFamily="50" charset="0"/>
+              <a:ea typeface="+mn-ea"/>
+              <a:cs typeface="+mn-cs"/>
+            </a:endParaRPr>
+          </a:p>
+          <a:p>
+            <a:pPr marR="0" lvl="0" algn="just" defTabSz="914400" rtl="0" eaLnBrk="1" fontAlgn="auto" latinLnBrk="0" hangingPunct="1">
+              <a:lnSpc>
+                <a:spcPct val="150000"/>
+              </a:lnSpc>
+              <a:spcBef>
+                <a:spcPts val="0"/>
+              </a:spcBef>
+              <a:spcAft>
+                <a:spcPts val="0"/>
+              </a:spcAft>
+              <a:buClrTx/>
+              <a:buSzTx/>
+              <a:tabLst/>
+              <a:defRPr/>
+            </a:pPr>
+            <a:r>
+              <a:rPr kumimoji="0" lang="en-US" sz="2000" b="0" i="0" u="none" strike="noStrike" kern="1200" cap="none" spc="0" normalizeH="0" baseline="0" noProof="0" dirty="0">
+                <a:ln>
+                  <a:noFill/>
+                </a:ln>
+                <a:solidFill>
+                  <a:prstClr val="black"/>
+                </a:solidFill>
+                <a:effectLst/>
+                <a:uLnTx/>
+                <a:uFillTx/>
+                <a:latin typeface="UT Sans" pitchFamily="50" charset="0"/>
+                <a:ea typeface="+mn-ea"/>
+                <a:cs typeface="+mn-cs"/>
+              </a:rPr>
+              <a:t>• </a:t>
+            </a:r>
+            <a:r>
+              <a:rPr lang="ro-RO" sz="2000" dirty="0">
+                <a:solidFill>
+                  <a:prstClr val="black"/>
+                </a:solidFill>
+                <a:latin typeface="UT Sans" pitchFamily="50" charset="0"/>
+              </a:rPr>
+              <a:t>Circuit de protecție la scurtcircuit la alimentare (e-Fuse)</a:t>
+            </a:r>
+            <a:endParaRPr kumimoji="0" lang="en-US" sz="2000" b="0" i="0" u="none" strike="noStrike" kern="1200" cap="none" spc="0" normalizeH="0" baseline="0" noProof="0" dirty="0">
+              <a:ln>
+                <a:noFill/>
+              </a:ln>
+              <a:solidFill>
+                <a:prstClr val="black"/>
+              </a:solidFill>
+              <a:effectLst/>
+              <a:uLnTx/>
+              <a:uFillTx/>
+              <a:latin typeface="UT Sans" pitchFamily="50" charset="0"/>
+              <a:ea typeface="+mn-ea"/>
+              <a:cs typeface="+mn-cs"/>
+            </a:endParaRPr>
+          </a:p>
+          <a:p>
+            <a:pPr marR="0" lvl="0" algn="just" defTabSz="914400" rtl="0" eaLnBrk="1" fontAlgn="auto" latinLnBrk="0" hangingPunct="1">
+              <a:lnSpc>
+                <a:spcPct val="150000"/>
+              </a:lnSpc>
+              <a:spcBef>
+                <a:spcPts val="0"/>
+              </a:spcBef>
+              <a:spcAft>
+                <a:spcPts val="0"/>
+              </a:spcAft>
+              <a:buClrTx/>
+              <a:buSzTx/>
+              <a:tabLst/>
+              <a:defRPr/>
+            </a:pPr>
+            <a:r>
+              <a:rPr kumimoji="0" lang="en-US" sz="2000" b="0" i="0" u="none" strike="noStrike" kern="1200" cap="none" spc="0" normalizeH="0" baseline="0" noProof="0" dirty="0">
+                <a:ln>
+                  <a:noFill/>
+                </a:ln>
+                <a:solidFill>
+                  <a:prstClr val="black"/>
+                </a:solidFill>
+                <a:effectLst/>
+                <a:uLnTx/>
+                <a:uFillTx/>
+                <a:latin typeface="UT Sans" pitchFamily="50" charset="0"/>
+                <a:ea typeface="+mn-ea"/>
+                <a:cs typeface="+mn-cs"/>
+              </a:rPr>
+              <a:t>• </a:t>
+            </a:r>
+            <a:r>
+              <a:rPr kumimoji="0" lang="ro-RO" sz="2000" b="0" i="0" u="none" strike="noStrike" kern="1200" cap="none" spc="0" normalizeH="0" baseline="0" noProof="0" dirty="0">
+                <a:ln>
+                  <a:noFill/>
+                </a:ln>
+                <a:solidFill>
+                  <a:prstClr val="black"/>
+                </a:solidFill>
+                <a:effectLst/>
+                <a:uLnTx/>
+                <a:uFillTx/>
+                <a:latin typeface="UT Sans" pitchFamily="50" charset="0"/>
+                <a:ea typeface="+mn-ea"/>
+                <a:cs typeface="+mn-cs"/>
+              </a:rPr>
+              <a:t>Comunicație digitală izolată prin izolatori cu cuplaj inductiv și optocuploare</a:t>
+            </a:r>
+            <a:endParaRPr kumimoji="0" lang="en-US" sz="2000" b="0" i="0" u="none" strike="noStrike" kern="1200" cap="none" spc="0" normalizeH="0" baseline="0" noProof="0" dirty="0">
+              <a:ln>
+                <a:noFill/>
+              </a:ln>
+              <a:solidFill>
+                <a:prstClr val="black"/>
+              </a:solidFill>
+              <a:effectLst/>
+              <a:uLnTx/>
+              <a:uFillTx/>
+              <a:latin typeface="UT Sans" pitchFamily="50" charset="0"/>
+              <a:ea typeface="+mn-ea"/>
+              <a:cs typeface="+mn-cs"/>
+            </a:endParaRPr>
+          </a:p>
+          <a:p>
+            <a:pPr marR="0" lvl="0" algn="just" defTabSz="914400" rtl="0" eaLnBrk="1" fontAlgn="auto" latinLnBrk="0" hangingPunct="1">
+              <a:lnSpc>
+                <a:spcPct val="150000"/>
+              </a:lnSpc>
+              <a:spcBef>
+                <a:spcPts val="0"/>
+              </a:spcBef>
+              <a:spcAft>
+                <a:spcPts val="0"/>
+              </a:spcAft>
+              <a:buClrTx/>
+              <a:buSzTx/>
+              <a:tabLst/>
+              <a:defRPr/>
+            </a:pPr>
+            <a:r>
+              <a:rPr kumimoji="0" lang="en-US" sz="2000" b="0" i="0" u="none" strike="noStrike" kern="1200" cap="none" spc="0" normalizeH="0" baseline="0" noProof="0" dirty="0">
+                <a:ln>
+                  <a:noFill/>
+                </a:ln>
+                <a:solidFill>
+                  <a:prstClr val="black"/>
+                </a:solidFill>
+                <a:effectLst/>
+                <a:uLnTx/>
+                <a:uFillTx/>
+                <a:latin typeface="UT Sans" pitchFamily="50" charset="0"/>
+                <a:ea typeface="+mn-ea"/>
+                <a:cs typeface="+mn-cs"/>
+              </a:rPr>
+              <a:t>• </a:t>
+            </a:r>
+            <a:r>
+              <a:rPr kumimoji="0" lang="ro-RO" sz="2000" b="0" i="0" u="none" strike="noStrike" kern="1200" cap="none" spc="0" normalizeH="0" baseline="0" noProof="0" dirty="0">
+                <a:ln>
+                  <a:noFill/>
+                </a:ln>
+                <a:solidFill>
+                  <a:prstClr val="black"/>
+                </a:solidFill>
+                <a:effectLst/>
+                <a:uLnTx/>
+                <a:uFillTx/>
+                <a:latin typeface="UT Sans" pitchFamily="50" charset="0"/>
+                <a:ea typeface="+mn-ea"/>
+                <a:cs typeface="+mn-cs"/>
+              </a:rPr>
+              <a:t>ADC cu </a:t>
+            </a:r>
+            <a:r>
+              <a:rPr lang="ro-RO" sz="2000" dirty="0">
+                <a:solidFill>
+                  <a:prstClr val="black"/>
+                </a:solidFill>
+                <a:latin typeface="UT Sans" pitchFamily="50" charset="0"/>
+              </a:rPr>
+              <a:t>aproximări succesive configurabil </a:t>
+            </a:r>
+            <a:endParaRPr kumimoji="0" lang="en-US" sz="2000" b="0" i="0" u="none" strike="noStrike" kern="1200" cap="none" spc="0" normalizeH="0" baseline="0" noProof="0" dirty="0">
+              <a:ln>
+                <a:noFill/>
+              </a:ln>
+              <a:solidFill>
+                <a:prstClr val="black"/>
+              </a:solidFill>
+              <a:effectLst/>
+              <a:uLnTx/>
+              <a:uFillTx/>
+              <a:latin typeface="UT Sans" pitchFamily="50" charset="0"/>
+              <a:ea typeface="+mn-ea"/>
+              <a:cs typeface="+mn-cs"/>
+            </a:endParaRPr>
+          </a:p>
+        </p:txBody>
+      </p:sp>
+      <p:pic>
+        <p:nvPicPr>
+          <p:cNvPr id="2" name="Picture 1"/>
+          <p:cNvPicPr>
+            <a:picLocks noChangeAspect="1"/>
+          </p:cNvPicPr>
+          <p:nvPr/>
+        </p:nvPicPr>
+        <p:blipFill>
+          <a:blip r:embed="rId2" cstate="print">
+            <a:extLst>
+              <a:ext uri="{28A0092B-C50C-407E-A947-70E740481C1C}">
+                <a14:useLocalDpi xmlns:a14="http://schemas.microsoft.com/office/drawing/2010/main" val="0"/>
+              </a:ext>
+            </a:extLst>
+          </a:blip>
+          <a:stretch>
+            <a:fillRect/>
+          </a:stretch>
+        </p:blipFill>
+        <p:spPr>
+          <a:xfrm>
+            <a:off x="359532" y="341671"/>
+            <a:ext cx="1944216" cy="531045"/>
+          </a:xfrm>
+          <a:prstGeom prst="rect">
+            <a:avLst/>
+          </a:prstGeom>
+        </p:spPr>
+      </p:pic>
+      <p:sp>
+        <p:nvSpPr>
+          <p:cNvPr id="9" name="TextBox 8">
+            <a:extLst>
+              <a:ext uri="{FF2B5EF4-FFF2-40B4-BE49-F238E27FC236}">
+                <a16:creationId xmlns:a16="http://schemas.microsoft.com/office/drawing/2014/main" id="{569E954C-8956-D007-11B6-AB54FF84615A}"/>
+              </a:ext>
+            </a:extLst>
+          </p:cNvPr>
+          <p:cNvSpPr txBox="1"/>
+          <p:nvPr/>
+        </p:nvSpPr>
+        <p:spPr>
+          <a:xfrm>
+            <a:off x="3095836" y="512676"/>
+            <a:ext cx="5310590" cy="400110"/>
+          </a:xfrm>
+          <a:prstGeom prst="rect">
+            <a:avLst/>
+          </a:prstGeom>
+          <a:noFill/>
+        </p:spPr>
+        <p:txBody>
+          <a:bodyPr wrap="square" rtlCol="0">
+            <a:spAutoFit/>
+          </a:bodyPr>
+          <a:lstStyle/>
+          <a:p>
+            <a:pPr algn="r"/>
+            <a:r>
+              <a:rPr lang="ro-RO" sz="2000" dirty="0"/>
+              <a:t>Specificații hardware finale</a:t>
+            </a:r>
+          </a:p>
+        </p:txBody>
+      </p:sp>
+    </p:spTree>
+    <p:extLst>
+      <p:ext uri="{BB962C8B-B14F-4D97-AF65-F5344CB8AC3E}">
+        <p14:creationId xmlns:p14="http://schemas.microsoft.com/office/powerpoint/2010/main" val="2525232200"/>
       </p:ext>
     </p:extLst>
   </p:cSld>
@@ -5368,7 +7390,7 @@
   <a:extraClrSchemeLst/>
   <a:extLst>
     <a:ext uri="{05A4C25C-085E-4340-85A3-A5531E510DB2}">
-      <thm15:themeFamily xmlns="" xmlns:thm15="http://schemas.microsoft.com/office/thememl/2012/main" name="Office Theme" id="{62F939B6-93AF-4DB8-9C6B-D6C7DFDC589F}" vid="{4A3C46E8-61CC-4603-A589-7422A47A8E4A}"/>
+      <thm15:themeFamily xmlns:thm15="http://schemas.microsoft.com/office/thememl/2012/main" name="Office Theme" id="{62F939B6-93AF-4DB8-9C6B-D6C7DFDC589F}" vid="{4A3C46E8-61CC-4603-A589-7422A47A8E4A}"/>
     </a:ext>
   </a:extLst>
 </a:theme>

</xml_diff>